<commit_message>
docs: presentation v3 — requirements-met evidence + review questions
All-green requirements status slide, per-requirement evidence with ask-boxes
retained, reports marked complete with screenshot paste-placeholders (report
lives on Karol's machine), script-mechanics checklist, updated open-questions
slide (incl. Q10 sub-question and 2025 embargo).

Co-Authored-By: Claude Fable 5 <noreply@anthropic.com>
</commit_message>
<xml_diff>
--- a/docs/prezentacja_obrona.pptx
+++ b/docs/prezentacja_obrona.pptx
@@ -19,6 +19,8 @@
     <p:sldId id="267" r:id="rId18"/>
     <p:sldId id="268" r:id="rId19"/>
     <p:sldId id="269" r:id="rId20"/>
+    <p:sldId id="270" r:id="rId21"/>
+    <p:sldId id="271" r:id="rId22"/>
   </p:sldIdLst>
   <p:sldSz cx="12191695" cy="6858000" type="screen4x3"/>
   <p:notesSz cx="6858000" cy="9144000"/>
@@ -3176,13 +3178,13 @@
           <a:p>
             <a:pPr algn="l"/>
             <a:r>
-              <a:rPr sz="3800" b="1">
+              <a:rPr sz="3600" b="1">
                 <a:solidFill>
                   <a:srgbClr val="FFFFFF"/>
                 </a:solidFill>
                 <a:latin typeface="Segoe UI"/>
               </a:rPr>
-              <a:t>Hurtownia danych ACLED — przegląd realizacji</a:t>
+              <a:t>Hurtownia danych ACLED — realizacja wymagań</a:t>
             </a:r>
           </a:p>
         </p:txBody>
@@ -3217,7 +3219,7 @@
                 </a:solidFill>
                 <a:latin typeface="Segoe UI"/>
               </a:rPr>
-              <a:t>Pokazujemy wszystko, co mamy — prosimy o ocenę, czy taka realizacja</a:t>
+              <a:t>Wszystkie punkty wymagań zrealizowane — przedstawiamy dowody</a:t>
             </a:r>
           </a:p>
           <a:p>
@@ -3229,7 +3231,7 @@
                 </a:solidFill>
                 <a:latin typeface="Segoe UI"/>
               </a:rPr>
-              <a:t>spełnia wymagania projektu (i co poprawić, zanim będzie za późno).</a:t>
+              <a:t>i prosimy o weryfikację decyzji projektowych.</a:t>
             </a:r>
           </a:p>
         </p:txBody>
@@ -3403,7 +3405,7 @@
                 </a:solidFill>
                 <a:latin typeface="Segoe UI"/>
               </a:rPr>
-              <a:t>Warstwa semantyczna — model Power BI</a:t>
+              <a:t>Jakość danych — wykryte i naprawione (12 błędów)</a:t>
             </a:r>
           </a:p>
         </p:txBody>
@@ -3423,7 +3425,7 @@
             <a:avLst/>
           </a:prstGeom>
           <a:solidFill>
-            <a:srgbClr val="E08E45"/>
+            <a:srgbClr val="2E7D32"/>
           </a:solidFill>
           <a:ln>
             <a:noFill/>
@@ -3455,7 +3457,7 @@
                 </a:solidFill>
                 <a:latin typeface="Segoe UI"/>
               </a:rPr>
-              <a:t>wymóg 10 pkt</a:t>
+              <a:t>bonus</a:t>
             </a:r>
           </a:p>
         </p:txBody>
@@ -3468,8 +3470,8 @@
         </p:nvSpPr>
         <p:spPr>
           <a:xfrm>
-            <a:off x="548640" y="1234440"/>
-            <a:ext cx="6035040" cy="4754880"/>
+            <a:off x="548640" y="1280160"/>
+            <a:ext cx="11155680" cy="4572000"/>
           </a:xfrm>
           <a:prstGeom prst="rect">
             <a:avLst/>
@@ -3489,7 +3491,18 @@
                 </a:solidFill>
                 <a:latin typeface="Segoe UI"/>
               </a:rPr>
-              <a:t>• Import gwiazdy przez ODBC/Athena (tryb Import)</a:t>
+              <a:t>• Cudzysłowy w CSV psuły kolumny LICZBOWE przy odczycie z Athena — suma ofiar 7× zaniżona (324 tys. vs 2,35 mln)</a:t>
+            </a:r>
+          </a:p>
+          <a:p>
+            <a:r>
+              <a:rPr sz="1400" b="0">
+                <a:solidFill>
+                  <a:srgbClr val="6B6B7B"/>
+                </a:solidFill>
+                <a:latin typeface="Segoe UI"/>
+              </a:rPr>
+              <a:t>   – wykryte rekoncyliacją dwóch niezależnych ścieżek liczenia; liczba WIERSZY zgadzała się idealnie — dlatego walidujemy 2 metryki</a:t>
             </a:r>
           </a:p>
           <a:p>
@@ -3500,18 +3513,18 @@
                 </a:solidFill>
                 <a:latin typeface="Segoe UI"/>
               </a:rPr>
-              <a:t>• 7 relacji *:1 — wymiar filtruje fakt</a:t>
-            </a:r>
-          </a:p>
-          <a:p>
-            <a:r>
-              <a:rPr sz="1400" b="0">
-                <a:solidFill>
-                  <a:srgbClr val="6B6B7B"/>
-                </a:solidFill>
-                <a:latin typeface="Segoe UI"/>
-              </a:rPr>
-              <a:t>   – populacja: cross-filter Both (inaczej per capita liczy się źle)</a:t>
+              <a:t>• Cast interaction→INT kasował kolumnę tekstową w silverze — obejście hybrydą z bronze</a:t>
+            </a:r>
+          </a:p>
+          <a:p>
+            <a:r>
+              <a:rPr sz="1600" b="0">
+                <a:solidFill>
+                  <a:srgbClr val="1A1A2E"/>
+                </a:solidFill>
+                <a:latin typeface="Segoe UI"/>
+              </a:rPr>
+              <a:t>• Pseudo-nulle → Unknown(−1) · dziurawy kalendarz → sequence() · duplikat skryptu Glue po restrukturyzacji repo</a:t>
             </a:r>
           </a:p>
           <a:p>
@@ -3522,290 +3535,18 @@
                 </a:solidFill>
                 <a:latin typeface="Segoe UI"/>
               </a:rPr>
-              <a:t>• 15 miar DAX</a:t>
-            </a:r>
-          </a:p>
-          <a:p>
-            <a:r>
-              <a:rPr sz="1400" b="0">
-                <a:solidFill>
-                  <a:srgbClr val="6B6B7B"/>
-                </a:solidFill>
-                <a:latin typeface="Segoe UI"/>
-              </a:rPr>
-              <a:t>   – SUM/COUNTROWS/DIVIDE · CALCULATE (protesty vs przemoc)</a:t>
-            </a:r>
-          </a:p>
-          <a:p>
-            <a:r>
-              <a:rPr sz="1400" b="0">
-                <a:solidFill>
-                  <a:srgbClr val="6B6B7B"/>
-                </a:solidFill>
-                <a:latin typeface="Segoe UI"/>
-              </a:rPr>
-              <a:t>   – DATEADD → YoY · DISTINCTCOUNT · per-100k</a:t>
-            </a:r>
-          </a:p>
-          <a:p>
-            <a:r>
-              <a:rPr sz="1600" b="1">
+              <a:t>• Walidacja automatyczna po KAŻDYM runie: silver == gold == fakt (zdarzenia + ofiary)</a:t>
+            </a:r>
+          </a:p>
+          <a:p>
+            <a:r>
+              <a:rPr sz="1600" b="0">
                 <a:solidFill>
                   <a:srgbClr val="1A1A2E"/>
                 </a:solidFill>
                 <a:latin typeface="Segoe UI"/>
               </a:rPr>
-              <a:t>• 3 hierarchie z drill-down + sort miesięcy po numerze</a:t>
-            </a:r>
-          </a:p>
-          <a:p>
-            <a:r>
-              <a:rPr sz="1400" b="0">
-                <a:solidFill>
-                  <a:srgbClr val="6B6B7B"/>
-                </a:solidFill>
-                <a:latin typeface="Segoe UI"/>
-              </a:rPr>
-              <a:t>   – Rok→Kwartał→Miesiąc · Region→Kraj · Disorder→Event→Sub</a:t>
-            </a:r>
-          </a:p>
-          <a:p>
-            <a:r>
-              <a:rPr sz="1600" b="0">
-                <a:solidFill>
-                  <a:srgbClr val="1A1A2E"/>
-                </a:solidFill>
-                <a:latin typeface="Segoe UI"/>
-              </a:rPr>
-              <a:t>• dim_date oznaczona jako tabela dat</a:t>
-            </a:r>
-          </a:p>
-          <a:p>
-            <a:r>
-              <a:rPr sz="1600" b="1">
-                <a:solidFill>
-                  <a:srgbClr val="1A1A2E"/>
-                </a:solidFill>
-                <a:latin typeface="Segoe UI"/>
-              </a:rPr>
-              <a:t>• Jeden model odpowiada na WSZYSTKIE 12 pytań</a:t>
-            </a:r>
-          </a:p>
-        </p:txBody>
-      </p:sp>
-      <p:sp>
-        <p:nvSpPr>
-          <p:cNvPr id="6" name="Rectangle 5"/>
-          <p:cNvSpPr/>
-          <p:nvPr/>
-        </p:nvSpPr>
-        <p:spPr>
-          <a:xfrm>
-            <a:off x="6858000" y="1463040"/>
-            <a:ext cx="4754880" cy="3840480"/>
-          </a:xfrm>
-          <a:prstGeom prst="rect">
-            <a:avLst/>
-          </a:prstGeom>
-          <a:solidFill>
-            <a:srgbClr val="FFFFFF"/>
-          </a:solidFill>
-          <a:ln>
-            <a:solidFill>
-              <a:srgbClr val="1F6F8B"/>
-            </a:solidFill>
-          </a:ln>
-        </p:spPr>
-        <p:style>
-          <a:lnRef idx="1">
-            <a:schemeClr val="accent1"/>
-          </a:lnRef>
-          <a:fillRef idx="3">
-            <a:schemeClr val="accent1"/>
-          </a:fillRef>
-          <a:effectRef idx="2">
-            <a:schemeClr val="accent1"/>
-          </a:effectRef>
-          <a:fontRef idx="minor">
-            <a:schemeClr val="lt1"/>
-          </a:fontRef>
-        </p:style>
-        <p:txBody>
-          <a:bodyPr rtlCol="0" anchor="ctr"/>
-          <a:lstStyle/>
-          <a:p>
-            <a:pPr algn="ctr"/>
-          </a:p>
-        </p:txBody>
-      </p:sp>
-      <p:sp>
-        <p:nvSpPr>
-          <p:cNvPr id="7" name="TextBox 6"/>
-          <p:cNvSpPr txBox="1"/>
-          <p:nvPr/>
-        </p:nvSpPr>
-        <p:spPr>
-          <a:xfrm>
-            <a:off x="7132320" y="1691640"/>
-            <a:ext cx="4206240" cy="457200"/>
-          </a:xfrm>
-          <a:prstGeom prst="rect">
-            <a:avLst/>
-          </a:prstGeom>
-          <a:noFill/>
-        </p:spPr>
-        <p:txBody>
-          <a:bodyPr wrap="square">
-            <a:spAutoFit/>
-          </a:bodyPr>
-          <a:lstStyle/>
-          <a:p>
-            <a:pPr algn="l"/>
-            <a:r>
-              <a:rPr sz="1700" b="1">
-                <a:solidFill>
-                  <a:srgbClr val="1F6F8B"/>
-                </a:solidFill>
-                <a:latin typeface="Segoe UI"/>
-              </a:rPr>
-              <a:t>Rola SQL-i per-pytanie (gold_*)</a:t>
-            </a:r>
-          </a:p>
-        </p:txBody>
-      </p:sp>
-      <p:sp>
-        <p:nvSpPr>
-          <p:cNvPr id="8" name="TextBox 7"/>
-          <p:cNvSpPr txBox="1"/>
-          <p:nvPr/>
-        </p:nvSpPr>
-        <p:spPr>
-          <a:xfrm>
-            <a:off x="7132320" y="2194560"/>
-            <a:ext cx="4206240" cy="2926080"/>
-          </a:xfrm>
-          <a:prstGeom prst="rect">
-            <a:avLst/>
-          </a:prstGeom>
-          <a:noFill/>
-        </p:spPr>
-        <p:txBody>
-          <a:bodyPr wrap="square">
-            <a:spAutoFit/>
-          </a:bodyPr>
-          <a:lstStyle/>
-          <a:p>
-            <a:pPr algn="l"/>
-            <a:r>
-              <a:rPr sz="1500" b="0">
-                <a:solidFill>
-                  <a:srgbClr val="1A1A2E"/>
-                </a:solidFill>
-                <a:latin typeface="Segoe UI"/>
-              </a:rPr>
-              <a:t>To NIE jest warstwa semantyczna —</a:t>
-            </a:r>
-          </a:p>
-          <a:p>
-            <a:pPr algn="l"/>
-            <a:r>
-              <a:rPr sz="1500" b="0">
-                <a:solidFill>
-                  <a:srgbClr val="1A1A2E"/>
-                </a:solidFill>
-                <a:latin typeface="Segoe UI"/>
-              </a:rPr>
-              <a:t>to uzasadnienie doboru wymiarów</a:t>
-            </a:r>
-          </a:p>
-          <a:p>
-            <a:pPr algn="l"/>
-            <a:r>
-              <a:rPr sz="1500" b="0">
-                <a:solidFill>
-                  <a:srgbClr val="1A1A2E"/>
-                </a:solidFill>
-                <a:latin typeface="Segoe UI"/>
-              </a:rPr>
-              <a:t>i miar oraz niezależna ścieżka</a:t>
-            </a:r>
-          </a:p>
-          <a:p>
-            <a:pPr algn="l"/>
-            <a:r>
-              <a:rPr sz="1500" b="0">
-                <a:solidFill>
-                  <a:srgbClr val="1A1A2E"/>
-                </a:solidFill>
-                <a:latin typeface="Segoe UI"/>
-              </a:rPr>
-              <a:t>weryfikacji wyników (to ona wykryła</a:t>
-            </a:r>
-          </a:p>
-          <a:p>
-            <a:pPr algn="l"/>
-            <a:r>
-              <a:rPr sz="1500" b="0">
-                <a:solidFill>
-                  <a:srgbClr val="1A1A2E"/>
-                </a:solidFill>
-                <a:latin typeface="Segoe UI"/>
-              </a:rPr>
-              <a:t>błąd zaniżonych ofiar 7×).</a:t>
-            </a:r>
-          </a:p>
-        </p:txBody>
-      </p:sp>
-      <p:sp>
-        <p:nvSpPr>
-          <p:cNvPr id="9" name="Rectangle 8"/>
-          <p:cNvSpPr/>
-          <p:nvPr/>
-        </p:nvSpPr>
-        <p:spPr>
-          <a:xfrm>
-            <a:off x="457200" y="5806440"/>
-            <a:ext cx="11277295" cy="777240"/>
-          </a:xfrm>
-          <a:prstGeom prst="rect">
-            <a:avLst/>
-          </a:prstGeom>
-          <a:solidFill>
-            <a:srgbClr val="FFFFFF"/>
-          </a:solidFill>
-          <a:ln w="19050">
-            <a:solidFill>
-              <a:srgbClr val="A50F15"/>
-            </a:solidFill>
-          </a:ln>
-        </p:spPr>
-        <p:style>
-          <a:lnRef idx="1">
-            <a:schemeClr val="accent1"/>
-          </a:lnRef>
-          <a:fillRef idx="3">
-            <a:schemeClr val="accent1"/>
-          </a:fillRef>
-          <a:effectRef idx="2">
-            <a:schemeClr val="accent1"/>
-          </a:effectRef>
-          <a:fontRef idx="minor">
-            <a:schemeClr val="lt1"/>
-          </a:fontRef>
-        </p:style>
-        <p:txBody>
-          <a:bodyPr rtlCol="0" anchor="ctr" wrap="square"/>
-          <a:lstStyle/>
-          <a:p>
-            <a:pPr algn="ctr"/>
-            <a:r>
-              <a:rPr sz="1500" b="1">
-                <a:solidFill>
-                  <a:srgbClr val="A50F15"/>
-                </a:solidFill>
-                <a:latin typeface="Segoe UI"/>
-              </a:rPr>
-              <a:t>PYTANIE DO PANI:  czy model Power BI jest akceptowalny jako warstwa semantyczna (zamiast SSAS)?</a:t>
+              <a:t>• Test odporności: świeży ingest (2.07) dodał +198 zdarzeń — pipeline przetrawił bez zmiany linii kodu</a:t>
             </a:r>
           </a:p>
         </p:txBody>
@@ -3909,49 +3650,14 @@
                 </a:solidFill>
                 <a:latin typeface="Segoe UI"/>
               </a:rPr>
-              <a:t>Raporty — stan: W TRAKCIE</a:t>
-            </a:r>
-          </a:p>
-        </p:txBody>
-      </p:sp>
-      <p:sp>
-        <p:nvSpPr>
-          <p:cNvPr id="4" name="TextBox 3"/>
-          <p:cNvSpPr txBox="1"/>
-          <p:nvPr/>
-        </p:nvSpPr>
-        <p:spPr>
-          <a:xfrm>
-            <a:off x="457200" y="868680"/>
-            <a:ext cx="11277295" cy="365760"/>
-          </a:xfrm>
-          <a:prstGeom prst="rect">
-            <a:avLst/>
-          </a:prstGeom>
-          <a:noFill/>
-        </p:spPr>
-        <p:txBody>
-          <a:bodyPr wrap="square">
-            <a:spAutoFit/>
-          </a:bodyPr>
-          <a:lstStyle/>
-          <a:p>
-            <a:pPr algn="l"/>
-            <a:r>
-              <a:rPr sz="1400" b="0">
-                <a:solidFill>
-                  <a:srgbClr val="6B6B7B"/>
-                </a:solidFill>
-                <a:latin typeface="Segoe UI"/>
-              </a:rPr>
-              <a:t>model gotowy; strony klikamy według poniższego planu — do pokazania na zjeździe</a:t>
-            </a:r>
-          </a:p>
-        </p:txBody>
-      </p:sp>
-      <p:sp>
-        <p:nvSpPr>
-          <p:cNvPr id="5" name="Rectangle 4"/>
+              <a:t>Warstwa semantyczna — model Power BI</a:t>
+            </a:r>
+          </a:p>
+        </p:txBody>
+      </p:sp>
+      <p:sp>
+        <p:nvSpPr>
+          <p:cNvPr id="4" name="Rectangle 3"/>
           <p:cNvSpPr/>
           <p:nvPr/>
         </p:nvSpPr>
@@ -3964,7 +3670,7 @@
             <a:avLst/>
           </a:prstGeom>
           <a:solidFill>
-            <a:srgbClr val="E08E45"/>
+            <a:srgbClr val="2E7D32"/>
           </a:solidFill>
           <a:ln>
             <a:noFill/>
@@ -3996,21 +3702,21 @@
                 </a:solidFill>
                 <a:latin typeface="Segoe UI"/>
               </a:rPr>
-              <a:t>do dokończenia</a:t>
-            </a:r>
-          </a:p>
-        </p:txBody>
-      </p:sp>
-      <p:sp>
-        <p:nvSpPr>
-          <p:cNvPr id="6" name="TextBox 5"/>
+              <a:t>wymóg 10 pkt ✔</a:t>
+            </a:r>
+          </a:p>
+        </p:txBody>
+      </p:sp>
+      <p:sp>
+        <p:nvSpPr>
+          <p:cNvPr id="5" name="TextBox 4"/>
           <p:cNvSpPr txBox="1"/>
           <p:nvPr/>
         </p:nvSpPr>
         <p:spPr>
           <a:xfrm>
-            <a:off x="548640" y="1371600"/>
-            <a:ext cx="11155680" cy="4206240"/>
+            <a:off x="548640" y="1234440"/>
+            <a:ext cx="6035040" cy="4754880"/>
           </a:xfrm>
           <a:prstGeom prst="rect">
             <a:avLst/>
@@ -4030,7 +3736,7 @@
                 </a:solidFill>
                 <a:latin typeface="Segoe UI"/>
               </a:rPr>
-              <a:t>• Dashboard (pierwsza strona): 4 karty KPI + trend + struktura + slicery + przyciski nawigacji</a:t>
+              <a:t>• Import gwiazdy „na płasko" (ODBC/Athena)</a:t>
             </a:r>
           </a:p>
           <a:p>
@@ -4041,7 +3747,18 @@
                 </a:solidFill>
                 <a:latin typeface="Segoe UI"/>
               </a:rPr>
-              <a:t>• 7 stron = 12 pytań: mapa, słupkowe Top N, liniowe z legendą, macierz-heatmapa, punktowy, tabele rankingowe</a:t>
+              <a:t>• 7 relacji *:1 — wymiar filtruje fakt</a:t>
+            </a:r>
+          </a:p>
+          <a:p>
+            <a:r>
+              <a:rPr sz="1600" b="1">
+                <a:solidFill>
+                  <a:srgbClr val="1A1A2E"/>
+                </a:solidFill>
+                <a:latin typeface="Segoe UI"/>
+              </a:rPr>
+              <a:t>• 15+ miar DAX (SUM/COUNTROWS/DIVIDE/CALCULATE/DATEADD/DISTINCTCOUNT/RANKX)</a:t>
             </a:r>
           </a:p>
           <a:p>
@@ -4052,7 +3769,7 @@
                 </a:solidFill>
                 <a:latin typeface="Segoe UI"/>
               </a:rPr>
-              <a:t>• Mechaniki ze skryptu zajęć: slicery zsynchronizowane · drill-down · formatowanie warunkowe · interakcje</a:t>
+              <a:t>• 3 hierarchie z drill-down + chronologiczny sort miesięcy</a:t>
             </a:r>
           </a:p>
           <a:p>
@@ -4063,7 +3780,7 @@
                 </a:solidFill>
                 <a:latin typeface="Segoe UI"/>
               </a:rPr>
-              <a:t>• Zasady wizualizacji (wykład 8): słupki od zera, oś czasu chronologicznie, bez 3D</a:t>
+              <a:t>• dim_date oznaczona jako tabela dat; klucze techniczne ukryte</a:t>
             </a:r>
           </a:p>
           <a:p>
@@ -4074,14 +3791,200 @@
                 </a:solidFill>
                 <a:latin typeface="Segoe UI"/>
               </a:rPr>
-              <a:t>• Przykładowe odpowiedzi już z SQL: Ukraina 2022 +35 tys. (inwazja) · Palestyna #10→#1 per capita · Państwo–Rebelianci 612 tys. ofiar · Afryka Środkowa ~38% celowania w cywilów</a:t>
-            </a:r>
-          </a:p>
-        </p:txBody>
-      </p:sp>
-      <p:sp>
-        <p:nvSpPr>
-          <p:cNvPr id="7" name="Rectangle 6"/>
+              <a:t>• Jeden model odpowiada na WSZYSTKIE 12 pytań</a:t>
+            </a:r>
+          </a:p>
+          <a:p>
+            <a:r>
+              <a:rPr sz="1600" b="0">
+                <a:solidFill>
+                  <a:srgbClr val="1A1A2E"/>
+                </a:solidFill>
+                <a:latin typeface="Segoe UI"/>
+              </a:rPr>
+              <a:t>• SQL-e per-pytanie (gold_*) = uzasadnienie wymiarów i miar + niezależna weryfikacja wyników</a:t>
+            </a:r>
+          </a:p>
+        </p:txBody>
+      </p:sp>
+      <p:sp>
+        <p:nvSpPr>
+          <p:cNvPr id="6" name="Rectangle 5"/>
+          <p:cNvSpPr/>
+          <p:nvPr/>
+        </p:nvSpPr>
+        <p:spPr>
+          <a:xfrm>
+            <a:off x="6858000" y="1463040"/>
+            <a:ext cx="4754880" cy="3840480"/>
+          </a:xfrm>
+          <a:prstGeom prst="rect">
+            <a:avLst/>
+          </a:prstGeom>
+          <a:solidFill>
+            <a:srgbClr val="FFFFFF"/>
+          </a:solidFill>
+          <a:ln>
+            <a:solidFill>
+              <a:srgbClr val="1F6F8B"/>
+            </a:solidFill>
+          </a:ln>
+        </p:spPr>
+        <p:style>
+          <a:lnRef idx="1">
+            <a:schemeClr val="accent1"/>
+          </a:lnRef>
+          <a:fillRef idx="3">
+            <a:schemeClr val="accent1"/>
+          </a:fillRef>
+          <a:effectRef idx="2">
+            <a:schemeClr val="accent1"/>
+          </a:effectRef>
+          <a:fontRef idx="minor">
+            <a:schemeClr val="lt1"/>
+          </a:fontRef>
+        </p:style>
+        <p:txBody>
+          <a:bodyPr rtlCol="0" anchor="ctr"/>
+          <a:lstStyle/>
+          <a:p>
+            <a:pPr algn="ctr"/>
+          </a:p>
+        </p:txBody>
+      </p:sp>
+      <p:sp>
+        <p:nvSpPr>
+          <p:cNvPr id="7" name="TextBox 6"/>
+          <p:cNvSpPr txBox="1"/>
+          <p:nvPr/>
+        </p:nvSpPr>
+        <p:spPr>
+          <a:xfrm>
+            <a:off x="7132320" y="1691640"/>
+            <a:ext cx="4206240" cy="457200"/>
+          </a:xfrm>
+          <a:prstGeom prst="rect">
+            <a:avLst/>
+          </a:prstGeom>
+          <a:noFill/>
+        </p:spPr>
+        <p:txBody>
+          <a:bodyPr wrap="square">
+            <a:spAutoFit/>
+          </a:bodyPr>
+          <a:lstStyle/>
+          <a:p>
+            <a:pPr algn="l"/>
+            <a:r>
+              <a:rPr sz="1700" b="1">
+                <a:solidFill>
+                  <a:srgbClr val="1F6F8B"/>
+                </a:solidFill>
+                <a:latin typeface="Segoe UI"/>
+              </a:rPr>
+              <a:t>Zgodność ze skryptem zajęć</a:t>
+            </a:r>
+          </a:p>
+        </p:txBody>
+      </p:sp>
+      <p:sp>
+        <p:nvSpPr>
+          <p:cNvPr id="8" name="TextBox 7"/>
+          <p:cNvSpPr txBox="1"/>
+          <p:nvPr/>
+        </p:nvSpPr>
+        <p:spPr>
+          <a:xfrm>
+            <a:off x="7132320" y="2194560"/>
+            <a:ext cx="4206240" cy="3017520"/>
+          </a:xfrm>
+          <a:prstGeom prst="rect">
+            <a:avLst/>
+          </a:prstGeom>
+          <a:noFill/>
+        </p:spPr>
+        <p:txBody>
+          <a:bodyPr wrap="square">
+            <a:spAutoFit/>
+          </a:bodyPr>
+          <a:lstStyle/>
+          <a:p>
+            <a:pPr algn="l"/>
+            <a:r>
+              <a:rPr sz="1500" b="0">
+                <a:solidFill>
+                  <a:srgbClr val="1A1A2E"/>
+                </a:solidFill>
+                <a:latin typeface="Segoe UI"/>
+              </a:rPr>
+              <a:t>model przed wykresami ✔</a:t>
+            </a:r>
+          </a:p>
+          <a:p>
+            <a:pPr algn="l"/>
+            <a:r>
+              <a:rPr sz="1500" b="0">
+                <a:solidFill>
+                  <a:srgbClr val="1A1A2E"/>
+                </a:solidFill>
+                <a:latin typeface="Segoe UI"/>
+              </a:rPr>
+              <a:t>tryb Import ✔</a:t>
+            </a:r>
+          </a:p>
+          <a:p>
+            <a:pPr algn="l"/>
+            <a:r>
+              <a:rPr sz="1500" b="0">
+                <a:solidFill>
+                  <a:srgbClr val="1A1A2E"/>
+                </a:solidFill>
+                <a:latin typeface="Segoe UI"/>
+              </a:rPr>
+              <a:t>DIVIDE zamiast „/" ✔</a:t>
+            </a:r>
+          </a:p>
+          <a:p>
+            <a:pPr algn="l"/>
+            <a:r>
+              <a:rPr sz="1500" b="0">
+                <a:solidFill>
+                  <a:srgbClr val="1A1A2E"/>
+                </a:solidFill>
+                <a:latin typeface="Segoe UI"/>
+              </a:rPr>
+              <a:t>miary zamiast kolumn ✔</a:t>
+            </a:r>
+          </a:p>
+          <a:p>
+            <a:pPr algn="l"/>
+            <a:r>
+              <a:rPr sz="1500" b="0">
+                <a:solidFill>
+                  <a:srgbClr val="1A1A2E"/>
+                </a:solidFill>
+                <a:latin typeface="Segoe UI"/>
+              </a:rPr>
+              <a:t>foldery + formaty ✔</a:t>
+            </a:r>
+          </a:p>
+          <a:p>
+            <a:pPr algn="l"/>
+            <a:r>
+              <a:rPr sz="1500" b="0">
+                <a:solidFill>
+                  <a:srgbClr val="1A1A2E"/>
+                </a:solidFill>
+                <a:latin typeface="Segoe UI"/>
+              </a:rPr>
+              <a:t>ukryte klucze ✔</a:t>
+            </a:r>
+          </a:p>
+        </p:txBody>
+      </p:sp>
+      <p:sp>
+        <p:nvSpPr>
+          <p:cNvPr id="9" name="Rectangle 8"/>
           <p:cNvSpPr/>
           <p:nvPr/>
         </p:nvSpPr>
@@ -4128,7 +4031,7 @@
                 </a:solidFill>
                 <a:latin typeface="Segoe UI"/>
               </a:rPr>
-              <a:t>PYTANIE DO PANI:  czy taki układ raportu (dashboard + strona per pytanie) odpowiada oczekiwaniom?</a:t>
+              <a:t>PYTANIE DO PANI:  czy model Power BI jest akceptowalny jako warstwa semantyczna (zamiast SSAS)?</a:t>
             </a:r>
           </a:p>
         </p:txBody>
@@ -4232,7 +4135,7 @@
                 </a:solidFill>
                 <a:latin typeface="Segoe UI"/>
               </a:rPr>
-              <a:t>Jakość danych — co znaleźliśmy i naprawiliśmy</a:t>
+              <a:t>Raporty — Dashboard (strona startowa)</a:t>
             </a:r>
           </a:p>
         </p:txBody>
@@ -4252,7 +4155,7 @@
             <a:avLst/>
           </a:prstGeom>
           <a:solidFill>
-            <a:srgbClr val="E08E45"/>
+            <a:srgbClr val="2E7D32"/>
           </a:solidFill>
           <a:ln>
             <a:noFill/>
@@ -4284,21 +4187,85 @@
                 </a:solidFill>
                 <a:latin typeface="Segoe UI"/>
               </a:rPr>
-              <a:t>bonus</a:t>
-            </a:r>
-          </a:p>
-        </p:txBody>
-      </p:sp>
-      <p:sp>
-        <p:nvSpPr>
-          <p:cNvPr id="5" name="TextBox 4"/>
+              <a:t>wymóg 10 pkt ✔</a:t>
+            </a:r>
+          </a:p>
+        </p:txBody>
+      </p:sp>
+      <p:sp>
+        <p:nvSpPr>
+          <p:cNvPr id="5" name="Rectangle 4"/>
+          <p:cNvSpPr/>
+          <p:nvPr/>
+        </p:nvSpPr>
+        <p:spPr>
+          <a:xfrm>
+            <a:off x="457200" y="1234440"/>
+            <a:ext cx="8229600" cy="4846320"/>
+          </a:xfrm>
+          <a:prstGeom prst="rect">
+            <a:avLst/>
+          </a:prstGeom>
+          <a:solidFill>
+            <a:srgbClr val="ECECE8"/>
+          </a:solidFill>
+          <a:ln w="25400">
+            <a:solidFill>
+              <a:srgbClr val="E08E45"/>
+            </a:solidFill>
+          </a:ln>
+        </p:spPr>
+        <p:style>
+          <a:lnRef idx="1">
+            <a:schemeClr val="accent1"/>
+          </a:lnRef>
+          <a:fillRef idx="3">
+            <a:schemeClr val="accent1"/>
+          </a:fillRef>
+          <a:effectRef idx="2">
+            <a:schemeClr val="accent1"/>
+          </a:effectRef>
+          <a:fontRef idx="minor">
+            <a:schemeClr val="lt1"/>
+          </a:fontRef>
+        </p:style>
+        <p:txBody>
+          <a:bodyPr rtlCol="0" anchor="ctr" wrap="square"/>
+          <a:lstStyle/>
+          <a:p>
+            <a:pPr algn="ctr"/>
+            <a:r>
+              <a:rPr sz="1600" b="1">
+                <a:solidFill>
+                  <a:srgbClr val="E08E45"/>
+                </a:solidFill>
+                <a:latin typeface="Segoe UI"/>
+              </a:rPr>
+              <a:t>TU WKLEJ SCREEN DASHBOARDU</a:t>
+            </a:r>
+            <a:br/>
+            <a:r>
+              <a:rPr sz="1600" b="1">
+                <a:solidFill>
+                  <a:srgbClr val="E08E45"/>
+                </a:solidFill>
+                <a:latin typeface="Segoe UI"/>
+              </a:rPr>
+              <a:t>(otwórz .pbix → PrintScreen → Ctrl+V na tym slajdzie)</a:t>
+            </a:r>
+          </a:p>
+        </p:txBody>
+      </p:sp>
+      <p:sp>
+        <p:nvSpPr>
+          <p:cNvPr id="6" name="TextBox 5"/>
           <p:cNvSpPr txBox="1"/>
           <p:nvPr/>
         </p:nvSpPr>
         <p:spPr>
           <a:xfrm>
-            <a:off x="548640" y="1280160"/>
-            <a:ext cx="11155680" cy="4572000"/>
+            <a:off x="8915400" y="1371600"/>
+            <a:ext cx="3017520" cy="4754880"/>
           </a:xfrm>
           <a:prstGeom prst="rect">
             <a:avLst/>
@@ -4312,68 +4279,68 @@
           <a:lstStyle/>
           <a:p>
             <a:r>
-              <a:rPr sz="1600" b="1">
+              <a:rPr sz="1400" b="1">
                 <a:solidFill>
                   <a:srgbClr val="1A1A2E"/>
                 </a:solidFill>
                 <a:latin typeface="Segoe UI"/>
               </a:rPr>
-              <a:t>• Cudzysłowy w CSV psuły kolumny liczbowe przy odczycie przez Athenę — suma ofiar 7× zaniżona (324 tys. zamiast 2,35 mln)</a:t>
+              <a:t>• 4 karty KPI</a:t>
             </a:r>
           </a:p>
           <a:p>
             <a:r>
               <a:rPr sz="1400" b="0">
                 <a:solidFill>
+                  <a:srgbClr val="1A1A2E"/>
+                </a:solidFill>
+                <a:latin typeface="Segoe UI"/>
+              </a:rPr>
+              <a:t>• trend + struktura</a:t>
+            </a:r>
+          </a:p>
+          <a:p>
+            <a:r>
+              <a:rPr sz="1400" b="0">
+                <a:solidFill>
+                  <a:srgbClr val="1A1A2E"/>
+                </a:solidFill>
+                <a:latin typeface="Segoe UI"/>
+              </a:rPr>
+              <a:t>• TOP kraje / typy</a:t>
+            </a:r>
+          </a:p>
+          <a:p>
+            <a:r>
+              <a:rPr sz="1400" b="1">
+                <a:solidFill>
+                  <a:srgbClr val="1A1A2E"/>
+                </a:solidFill>
+                <a:latin typeface="Segoe UI"/>
+              </a:rPr>
+              <a:t>• slicery rok+region</a:t>
+            </a:r>
+          </a:p>
+          <a:p>
+            <a:r>
+              <a:rPr sz="1200" b="0">
+                <a:solidFill>
                   <a:srgbClr val="6B6B7B"/>
                 </a:solidFill>
                 <a:latin typeface="Segoe UI"/>
               </a:rPr>
-              <a:t>   – wykryte rekoncyliacją dwóch niezależnych ścieżek liczenia; fix: odczyt z Parquet silvera</a:t>
-            </a:r>
-          </a:p>
-          <a:p>
-            <a:r>
-              <a:rPr sz="1600" b="0">
+              <a:t>   – zsynchronizowane między stronami</a:t>
+            </a:r>
+          </a:p>
+          <a:p>
+            <a:r>
+              <a:rPr sz="1400" b="1">
                 <a:solidFill>
                   <a:srgbClr val="1A1A2E"/>
                 </a:solidFill>
                 <a:latin typeface="Segoe UI"/>
               </a:rPr>
-              <a:t>• Cast interaction→INT w jobie Spark kasował kolumnę (etykieta tekstowa) — obejście: hybryda z bronze</a:t>
-            </a:r>
-          </a:p>
-          <a:p>
-            <a:r>
-              <a:rPr sz="1600" b="0">
-                <a:solidFill>
-                  <a:srgbClr val="1A1A2E"/>
-                </a:solidFill>
-                <a:latin typeface="Segoe UI"/>
-              </a:rPr>
-              <a:t>• Pseudo-nulle („") → wiersz Unknown(−1); dziurawy kalendarz → ciągły sequence(); 12 błędów łącznie</a:t>
-            </a:r>
-          </a:p>
-          <a:p>
-            <a:r>
-              <a:rPr sz="1600" b="1">
-                <a:solidFill>
-                  <a:srgbClr val="1A1A2E"/>
-                </a:solidFill>
-                <a:latin typeface="Segoe UI"/>
-              </a:rPr>
-              <a:t>• Wniosek: walidacja automatyczna po każdym runie — liczba zdarzeń ORAZ suma miary, między warstwami</a:t>
-            </a:r>
-          </a:p>
-          <a:p>
-            <a:r>
-              <a:rPr sz="1600" b="0">
-                <a:solidFill>
-                  <a:srgbClr val="1A1A2E"/>
-                </a:solidFill>
-                <a:latin typeface="Segoe UI"/>
-              </a:rPr>
-              <a:t>• Dane żywe: świeży ingest (2.07) dodał +198 zdarzeń — pipeline przetrawił bez zmiany linii kodu</a:t>
+              <a:t>• nawigacja boczna do 8 stron</a:t>
             </a:r>
           </a:p>
         </p:txBody>
@@ -4477,7 +4444,7 @@
                 </a:solidFill>
                 <a:latin typeface="Segoe UI"/>
               </a:rPr>
-              <a:t>Pytania, na które potrzebujemy Pani decyzji</a:t>
+              <a:t>Raporty — 8 stron analitycznych = 12 pytań</a:t>
             </a:r>
           </a:p>
         </p:txBody>
@@ -4497,7 +4464,7 @@
             <a:avLst/>
           </a:prstGeom>
           <a:solidFill>
-            <a:srgbClr val="E08E45"/>
+            <a:srgbClr val="2E7D32"/>
           </a:solidFill>
           <a:ln>
             <a:noFill/>
@@ -4529,21 +4496,237 @@
                 </a:solidFill>
                 <a:latin typeface="Segoe UI"/>
               </a:rPr>
-              <a:t>PROSIMY O FEEDBACK</a:t>
-            </a:r>
-          </a:p>
-        </p:txBody>
-      </p:sp>
-      <p:sp>
-        <p:nvSpPr>
-          <p:cNvPr id="5" name="TextBox 4"/>
+              <a:t>wymóg ✔</a:t>
+            </a:r>
+          </a:p>
+        </p:txBody>
+      </p:sp>
+      <p:sp>
+        <p:nvSpPr>
+          <p:cNvPr id="5" name="Rectangle 4"/>
+          <p:cNvSpPr/>
+          <p:nvPr/>
+        </p:nvSpPr>
+        <p:spPr>
+          <a:xfrm>
+            <a:off x="457200" y="1234440"/>
+            <a:ext cx="5486400" cy="2377440"/>
+          </a:xfrm>
+          <a:prstGeom prst="rect">
+            <a:avLst/>
+          </a:prstGeom>
+          <a:solidFill>
+            <a:srgbClr val="ECECE8"/>
+          </a:solidFill>
+          <a:ln w="25400">
+            <a:solidFill>
+              <a:srgbClr val="E08E45"/>
+            </a:solidFill>
+          </a:ln>
+        </p:spPr>
+        <p:style>
+          <a:lnRef idx="1">
+            <a:schemeClr val="accent1"/>
+          </a:lnRef>
+          <a:fillRef idx="3">
+            <a:schemeClr val="accent1"/>
+          </a:fillRef>
+          <a:effectRef idx="2">
+            <a:schemeClr val="accent1"/>
+          </a:effectRef>
+          <a:fontRef idx="minor">
+            <a:schemeClr val="lt1"/>
+          </a:fontRef>
+        </p:style>
+        <p:txBody>
+          <a:bodyPr rtlCol="0" anchor="ctr" wrap="square"/>
+          <a:lstStyle/>
+          <a:p>
+            <a:pPr algn="ctr"/>
+            <a:r>
+              <a:rPr sz="1600" b="1">
+                <a:solidFill>
+                  <a:srgbClr val="E08E45"/>
+                </a:solidFill>
+                <a:latin typeface="Segoe UI"/>
+              </a:rPr>
+              <a:t>TU WKLEJ SCREEN: 01 Geografia (Q1–2)</a:t>
+            </a:r>
+          </a:p>
+        </p:txBody>
+      </p:sp>
+      <p:sp>
+        <p:nvSpPr>
+          <p:cNvPr id="6" name="Rectangle 5"/>
+          <p:cNvSpPr/>
+          <p:nvPr/>
+        </p:nvSpPr>
+        <p:spPr>
+          <a:xfrm>
+            <a:off x="6355080" y="1234440"/>
+            <a:ext cx="5486400" cy="2377440"/>
+          </a:xfrm>
+          <a:prstGeom prst="rect">
+            <a:avLst/>
+          </a:prstGeom>
+          <a:solidFill>
+            <a:srgbClr val="ECECE8"/>
+          </a:solidFill>
+          <a:ln w="25400">
+            <a:solidFill>
+              <a:srgbClr val="E08E45"/>
+            </a:solidFill>
+          </a:ln>
+        </p:spPr>
+        <p:style>
+          <a:lnRef idx="1">
+            <a:schemeClr val="accent1"/>
+          </a:lnRef>
+          <a:fillRef idx="3">
+            <a:schemeClr val="accent1"/>
+          </a:fillRef>
+          <a:effectRef idx="2">
+            <a:schemeClr val="accent1"/>
+          </a:effectRef>
+          <a:fontRef idx="minor">
+            <a:schemeClr val="lt1"/>
+          </a:fontRef>
+        </p:style>
+        <p:txBody>
+          <a:bodyPr rtlCol="0" anchor="ctr" wrap="square"/>
+          <a:lstStyle/>
+          <a:p>
+            <a:pPr algn="ctr"/>
+            <a:r>
+              <a:rPr sz="1600" b="1">
+                <a:solidFill>
+                  <a:srgbClr val="E08E45"/>
+                </a:solidFill>
+                <a:latin typeface="Segoe UI"/>
+              </a:rPr>
+              <a:t>TU WKLEJ SCREEN: 03 Sezonowość — heatmapa (Q4)</a:t>
+            </a:r>
+          </a:p>
+        </p:txBody>
+      </p:sp>
+      <p:sp>
+        <p:nvSpPr>
+          <p:cNvPr id="7" name="Rectangle 6"/>
+          <p:cNvSpPr/>
+          <p:nvPr/>
+        </p:nvSpPr>
+        <p:spPr>
+          <a:xfrm>
+            <a:off x="457200" y="3840480"/>
+            <a:ext cx="5486400" cy="2377440"/>
+          </a:xfrm>
+          <a:prstGeom prst="rect">
+            <a:avLst/>
+          </a:prstGeom>
+          <a:solidFill>
+            <a:srgbClr val="ECECE8"/>
+          </a:solidFill>
+          <a:ln w="25400">
+            <a:solidFill>
+              <a:srgbClr val="E08E45"/>
+            </a:solidFill>
+          </a:ln>
+        </p:spPr>
+        <p:style>
+          <a:lnRef idx="1">
+            <a:schemeClr val="accent1"/>
+          </a:lnRef>
+          <a:fillRef idx="3">
+            <a:schemeClr val="accent1"/>
+          </a:fillRef>
+          <a:effectRef idx="2">
+            <a:schemeClr val="accent1"/>
+          </a:effectRef>
+          <a:fontRef idx="minor">
+            <a:schemeClr val="lt1"/>
+          </a:fontRef>
+        </p:style>
+        <p:txBody>
+          <a:bodyPr rtlCol="0" anchor="ctr" wrap="square"/>
+          <a:lstStyle/>
+          <a:p>
+            <a:pPr algn="ctr"/>
+            <a:r>
+              <a:rPr sz="1600" b="1">
+                <a:solidFill>
+                  <a:srgbClr val="E08E45"/>
+                </a:solidFill>
+                <a:latin typeface="Segoe UI"/>
+              </a:rPr>
+              <a:t>TU WKLEJ SCREEN: 07 Eskalacja — YoY (Q11)</a:t>
+            </a:r>
+          </a:p>
+        </p:txBody>
+      </p:sp>
+      <p:sp>
+        <p:nvSpPr>
+          <p:cNvPr id="8" name="Rectangle 7"/>
+          <p:cNvSpPr/>
+          <p:nvPr/>
+        </p:nvSpPr>
+        <p:spPr>
+          <a:xfrm>
+            <a:off x="6355080" y="3840480"/>
+            <a:ext cx="5486400" cy="2377440"/>
+          </a:xfrm>
+          <a:prstGeom prst="rect">
+            <a:avLst/>
+          </a:prstGeom>
+          <a:solidFill>
+            <a:srgbClr val="ECECE8"/>
+          </a:solidFill>
+          <a:ln w="25400">
+            <a:solidFill>
+              <a:srgbClr val="E08E45"/>
+            </a:solidFill>
+          </a:ln>
+        </p:spPr>
+        <p:style>
+          <a:lnRef idx="1">
+            <a:schemeClr val="accent1"/>
+          </a:lnRef>
+          <a:fillRef idx="3">
+            <a:schemeClr val="accent1"/>
+          </a:fillRef>
+          <a:effectRef idx="2">
+            <a:schemeClr val="accent1"/>
+          </a:effectRef>
+          <a:fontRef idx="minor">
+            <a:schemeClr val="lt1"/>
+          </a:fontRef>
+        </p:style>
+        <p:txBody>
+          <a:bodyPr rtlCol="0" anchor="ctr" wrap="square"/>
+          <a:lstStyle/>
+          <a:p>
+            <a:pPr algn="ctr"/>
+            <a:r>
+              <a:rPr sz="1600" b="1">
+                <a:solidFill>
+                  <a:srgbClr val="E08E45"/>
+                </a:solidFill>
+                <a:latin typeface="Segoe UI"/>
+              </a:rPr>
+              <a:t>TU WKLEJ SCREEN: 08 Per capita — flip rankingu (Q12)</a:t>
+            </a:r>
+          </a:p>
+        </p:txBody>
+      </p:sp>
+      <p:sp>
+        <p:nvSpPr>
+          <p:cNvPr id="9" name="TextBox 8"/>
           <p:cNvSpPr txBox="1"/>
           <p:nvPr/>
         </p:nvSpPr>
         <p:spPr>
           <a:xfrm>
-            <a:off x="548640" y="1280160"/>
-            <a:ext cx="11155680" cy="4937760"/>
+            <a:off x="457200" y="6355080"/>
+            <a:ext cx="11247120" cy="365760"/>
           </a:xfrm>
           <a:prstGeom prst="rect">
             <a:avLst/>
@@ -4556,91 +4739,15 @@
           </a:bodyPr>
           <a:lstStyle/>
           <a:p>
-            <a:r>
-              <a:rPr sz="1700" b="1">
-                <a:solidFill>
-                  <a:srgbClr val="1A1A2E"/>
-                </a:solidFill>
-                <a:latin typeface="Segoe UI"/>
-              </a:rPr>
-              <a:t>• 1. Czy SCHEMAT GWIAZDY jest poprawny? (kluczowe — prosimy o formalne „sprawdzenie schematu")</a:t>
-            </a:r>
-          </a:p>
-          <a:p>
-            <a:r>
-              <a:rPr sz="1700" b="0">
-                <a:solidFill>
-                  <a:srgbClr val="1A1A2E"/>
-                </a:solidFill>
-                <a:latin typeface="Segoe UI"/>
-              </a:rPr>
-              <a:t>• 2. Stack: Airflow + Athena/S3 + model Power BI zamiast SSIS/SSAS/SSRS — akceptowalny?</a:t>
-            </a:r>
-          </a:p>
-          <a:p>
-            <a:r>
-              <a:rPr sz="1700" b="0">
-                <a:solidFill>
-                  <a:srgbClr val="1A1A2E"/>
-                </a:solidFill>
-                <a:latin typeface="Segoe UI"/>
-              </a:rPr>
-              <a:t>• 3. event_id_cnty jako wymiar zdegenerowany — dopuszczalny? (liczność = liczności faktu)</a:t>
-            </a:r>
-          </a:p>
-          <a:p>
-            <a:r>
-              <a:rPr sz="1700" b="0">
-                <a:solidFill>
-                  <a:srgbClr val="1A1A2E"/>
-                </a:solidFill>
-                <a:latin typeface="Segoe UI"/>
-              </a:rPr>
-              <a:t>• 4. Klucz iso_year (iso·10000+rok) dla populacji — czy woli Pani inne rozwiązanie klucza złożonego?</a:t>
-            </a:r>
-          </a:p>
-          <a:p>
-            <a:r>
-              <a:rPr sz="1700" b="0">
-                <a:solidFill>
-                  <a:srgbClr val="1A1A2E"/>
-                </a:solidFill>
-                <a:latin typeface="Segoe UI"/>
-              </a:rPr>
-              <a:t>• 5. Rejestrowanie historii: SCD typ 1 (nadpisanie) + rejestr usunięć — wystarczające uzasadnienie?</a:t>
-            </a:r>
-          </a:p>
-          <a:p>
-            <a:r>
-              <a:rPr sz="1700" b="0">
-                <a:solidFill>
-                  <a:srgbClr val="1A1A2E"/>
-                </a:solidFill>
-                <a:latin typeface="Segoe UI"/>
-              </a:rPr>
-              <a:t>• 6. Rok 2025 jest niepełny (dane do czerwca) — jak prezentować YoY?</a:t>
-            </a:r>
-          </a:p>
-          <a:p>
-            <a:r>
-              <a:rPr sz="1700" b="0">
-                <a:solidFill>
-                  <a:srgbClr val="1A1A2E"/>
-                </a:solidFill>
-                <a:latin typeface="Segoe UI"/>
-              </a:rPr>
-              <a:t>• 7. Per capita: brak populacji dla Kosowa (brak kodu ISO numeric, 0,4% zdarzeń) — akceptowalna luka?</a:t>
-            </a:r>
-          </a:p>
-          <a:p>
-            <a:r>
-              <a:rPr sz="1700" b="0">
-                <a:solidFill>
-                  <a:srgbClr val="1A1A2E"/>
-                </a:solidFill>
-                <a:latin typeface="Segoe UI"/>
-              </a:rPr>
-              <a:t>• 8. Czy forma dowodów (screeny z Airflow) i tabeli mapowań odpowiada wymaganiom zadań?</a:t>
+            <a:pPr algn="l"/>
+            <a:r>
+              <a:rPr sz="1300" b="0">
+                <a:solidFill>
+                  <a:srgbClr val="6B6B7B"/>
+                </a:solidFill>
+                <a:latin typeface="Segoe UI"/>
+              </a:rPr>
+              <a:t>pozostałe strony: 02 Trendy (Q3) · 04 Typy zdarzeń (Q5–6) · 05 Aktorzy (Q7–8) · 06 Cywile (Q9) · 07 Źródła (Q10) — pokaz na żywo</a:t>
             </a:r>
           </a:p>
         </p:txBody>
@@ -4744,21 +4851,124 @@
                 </a:solidFill>
                 <a:latin typeface="Segoe UI"/>
               </a:rPr>
-              <a:t>Podsumowanie stanu</a:t>
-            </a:r>
-          </a:p>
-        </p:txBody>
-      </p:sp>
-      <p:sp>
-        <p:nvSpPr>
-          <p:cNvPr id="4" name="TextBox 3"/>
+              <a:t>Raporty — mechaniki wymagane na zajęciach</a:t>
+            </a:r>
+          </a:p>
+        </p:txBody>
+      </p:sp>
+      <p:sp>
+        <p:nvSpPr>
+          <p:cNvPr id="4" name="Rectangle 3"/>
+          <p:cNvSpPr/>
+          <p:nvPr/>
+        </p:nvSpPr>
+        <p:spPr>
+          <a:xfrm>
+            <a:off x="9448495" y="292608"/>
+            <a:ext cx="2286000" cy="502920"/>
+          </a:xfrm>
+          <a:prstGeom prst="rect">
+            <a:avLst/>
+          </a:prstGeom>
+          <a:solidFill>
+            <a:srgbClr val="2E7D32"/>
+          </a:solidFill>
+          <a:ln>
+            <a:noFill/>
+          </a:ln>
+        </p:spPr>
+        <p:style>
+          <a:lnRef idx="1">
+            <a:schemeClr val="accent1"/>
+          </a:lnRef>
+          <a:fillRef idx="3">
+            <a:schemeClr val="accent1"/>
+          </a:fillRef>
+          <a:effectRef idx="2">
+            <a:schemeClr val="accent1"/>
+          </a:effectRef>
+          <a:fontRef idx="minor">
+            <a:schemeClr val="lt1"/>
+          </a:fontRef>
+        </p:style>
+        <p:txBody>
+          <a:bodyPr rtlCol="0" anchor="ctr"/>
+          <a:lstStyle/>
+          <a:p>
+            <a:pPr algn="ctr"/>
+            <a:r>
+              <a:rPr sz="1500" b="1">
+                <a:solidFill>
+                  <a:srgbClr val="FFFFFF"/>
+                </a:solidFill>
+                <a:latin typeface="Segoe UI"/>
+              </a:rPr>
+              <a:t>checklist ✔</a:t>
+            </a:r>
+          </a:p>
+        </p:txBody>
+      </p:sp>
+      <p:sp>
+        <p:nvSpPr>
+          <p:cNvPr id="5" name="Rectangle 4"/>
+          <p:cNvSpPr/>
+          <p:nvPr/>
+        </p:nvSpPr>
+        <p:spPr>
+          <a:xfrm>
+            <a:off x="548640" y="1344168"/>
+            <a:ext cx="329184" cy="329184"/>
+          </a:xfrm>
+          <a:prstGeom prst="rect">
+            <a:avLst/>
+          </a:prstGeom>
+          <a:solidFill>
+            <a:srgbClr val="2E7D32"/>
+          </a:solidFill>
+          <a:ln>
+            <a:noFill/>
+          </a:ln>
+        </p:spPr>
+        <p:style>
+          <a:lnRef idx="1">
+            <a:schemeClr val="accent1"/>
+          </a:lnRef>
+          <a:fillRef idx="3">
+            <a:schemeClr val="accent1"/>
+          </a:fillRef>
+          <a:effectRef idx="2">
+            <a:schemeClr val="accent1"/>
+          </a:effectRef>
+          <a:fontRef idx="minor">
+            <a:schemeClr val="lt1"/>
+          </a:fontRef>
+        </p:style>
+        <p:txBody>
+          <a:bodyPr rtlCol="0" anchor="ctr"/>
+          <a:lstStyle/>
+          <a:p>
+            <a:pPr algn="ctr"/>
+            <a:r>
+              <a:rPr sz="1500" b="1">
+                <a:solidFill>
+                  <a:srgbClr val="FFFFFF"/>
+                </a:solidFill>
+              </a:rPr>
+              <a:t>✔</a:t>
+            </a:r>
+          </a:p>
+        </p:txBody>
+      </p:sp>
+      <p:sp>
+        <p:nvSpPr>
+          <p:cNvPr id="6" name="TextBox 5"/>
           <p:cNvSpPr txBox="1"/>
           <p:nvPr/>
         </p:nvSpPr>
         <p:spPr>
           <a:xfrm>
-            <a:off x="548640" y="1371600"/>
-            <a:ext cx="11155680" cy="3291840"/>
+            <a:off x="1051560" y="1325880"/>
+            <a:ext cx="4480560" cy="457200"/>
           </a:xfrm>
           <a:prstGeom prst="rect">
             <a:avLst/>
@@ -4771,50 +4981,29 @@
           </a:bodyPr>
           <a:lstStyle/>
           <a:p>
-            <a:r>
-              <a:rPr sz="1800" b="1">
+            <a:pPr algn="l"/>
+            <a:r>
+              <a:rPr sz="1500" b="1">
                 <a:solidFill>
                   <a:srgbClr val="1A1A2E"/>
                 </a:solidFill>
                 <a:latin typeface="Segoe UI"/>
               </a:rPr>
-              <a:t>• GOTOWE: pipeline E2E (żywy, walidowany) · gwiazda · model semantyczny · mapowania · screeny · dokumentacja</a:t>
-            </a:r>
-          </a:p>
-          <a:p>
-            <a:r>
-              <a:rPr sz="1800" b="1">
-                <a:solidFill>
-                  <a:srgbClr val="1A1A2E"/>
-                </a:solidFill>
-                <a:latin typeface="Segoe UI"/>
-              </a:rPr>
-              <a:t>• W TRAKCIE: strony raportu w Power BI (model już stoi — zostało klikanie wykresów)</a:t>
-            </a:r>
-          </a:p>
-          <a:p>
-            <a:r>
-              <a:rPr sz="1800" b="0">
-                <a:solidFill>
-                  <a:srgbClr val="1A1A2E"/>
-                </a:solidFill>
-                <a:latin typeface="Segoe UI"/>
-              </a:rPr>
-              <a:t>• Wszystko w repozytorium — kod, SQL, DAG-i, diagramy, dowody</a:t>
-            </a:r>
-          </a:p>
-        </p:txBody>
-      </p:sp>
-      <p:sp>
-        <p:nvSpPr>
-          <p:cNvPr id="5" name="TextBox 4"/>
+              <a:t>Dashboard jako pierwsza strona + karty KPI</a:t>
+            </a:r>
+          </a:p>
+        </p:txBody>
+      </p:sp>
+      <p:sp>
+        <p:nvSpPr>
+          <p:cNvPr id="7" name="TextBox 6"/>
           <p:cNvSpPr txBox="1"/>
           <p:nvPr/>
         </p:nvSpPr>
         <p:spPr>
           <a:xfrm>
-            <a:off x="548640" y="4937760"/>
-            <a:ext cx="10972800" cy="914400"/>
+            <a:off x="5623560" y="1325880"/>
+            <a:ext cx="6309360" cy="457200"/>
           </a:xfrm>
           <a:prstGeom prst="rect">
             <a:avLst/>
@@ -4829,13 +5018,1322 @@
           <a:p>
             <a:pPr algn="l"/>
             <a:r>
+              <a:rPr sz="1300" b="0">
+                <a:solidFill>
+                  <a:srgbClr val="6B6B7B"/>
+                </a:solidFill>
+                <a:latin typeface="Segoe UI"/>
+              </a:rPr>
+              <a:t>szybkie zrozumienie sytuacji, potem szczegóły</a:t>
+            </a:r>
+          </a:p>
+        </p:txBody>
+      </p:sp>
+      <p:sp>
+        <p:nvSpPr>
+          <p:cNvPr id="8" name="Rectangle 7"/>
+          <p:cNvSpPr/>
+          <p:nvPr/>
+        </p:nvSpPr>
+        <p:spPr>
+          <a:xfrm>
+            <a:off x="548640" y="1947672"/>
+            <a:ext cx="329184" cy="329184"/>
+          </a:xfrm>
+          <a:prstGeom prst="rect">
+            <a:avLst/>
+          </a:prstGeom>
+          <a:solidFill>
+            <a:srgbClr val="2E7D32"/>
+          </a:solidFill>
+          <a:ln>
+            <a:noFill/>
+          </a:ln>
+        </p:spPr>
+        <p:style>
+          <a:lnRef idx="1">
+            <a:schemeClr val="accent1"/>
+          </a:lnRef>
+          <a:fillRef idx="3">
+            <a:schemeClr val="accent1"/>
+          </a:fillRef>
+          <a:effectRef idx="2">
+            <a:schemeClr val="accent1"/>
+          </a:effectRef>
+          <a:fontRef idx="minor">
+            <a:schemeClr val="lt1"/>
+          </a:fontRef>
+        </p:style>
+        <p:txBody>
+          <a:bodyPr rtlCol="0" anchor="ctr"/>
+          <a:lstStyle/>
+          <a:p>
+            <a:pPr algn="ctr"/>
+            <a:r>
+              <a:rPr sz="1500" b="1">
+                <a:solidFill>
+                  <a:srgbClr val="FFFFFF"/>
+                </a:solidFill>
+              </a:rPr>
+              <a:t>✔</a:t>
+            </a:r>
+          </a:p>
+        </p:txBody>
+      </p:sp>
+      <p:sp>
+        <p:nvSpPr>
+          <p:cNvPr id="9" name="TextBox 8"/>
+          <p:cNvSpPr txBox="1"/>
+          <p:nvPr/>
+        </p:nvSpPr>
+        <p:spPr>
+          <a:xfrm>
+            <a:off x="1051560" y="1929384"/>
+            <a:ext cx="4480560" cy="457200"/>
+          </a:xfrm>
+          <a:prstGeom prst="rect">
+            <a:avLst/>
+          </a:prstGeom>
+          <a:noFill/>
+        </p:spPr>
+        <p:txBody>
+          <a:bodyPr wrap="square">
+            <a:spAutoFit/>
+          </a:bodyPr>
+          <a:lstStyle/>
+          <a:p>
+            <a:pPr algn="l"/>
+            <a:r>
+              <a:rPr sz="1500" b="1">
+                <a:solidFill>
+                  <a:srgbClr val="1A1A2E"/>
+                </a:solidFill>
+                <a:latin typeface="Segoe UI"/>
+              </a:rPr>
+              <a:t>Slicery zsynchronizowane między stronami</a:t>
+            </a:r>
+          </a:p>
+        </p:txBody>
+      </p:sp>
+      <p:sp>
+        <p:nvSpPr>
+          <p:cNvPr id="10" name="TextBox 9"/>
+          <p:cNvSpPr txBox="1"/>
+          <p:nvPr/>
+        </p:nvSpPr>
+        <p:spPr>
+          <a:xfrm>
+            <a:off x="5623560" y="1929384"/>
+            <a:ext cx="6309360" cy="457200"/>
+          </a:xfrm>
+          <a:prstGeom prst="rect">
+            <a:avLst/>
+          </a:prstGeom>
+          <a:noFill/>
+        </p:spPr>
+        <p:txBody>
+          <a:bodyPr wrap="square">
+            <a:spAutoFit/>
+          </a:bodyPr>
+          <a:lstStyle/>
+          <a:p>
+            <a:pPr algn="l"/>
+            <a:r>
+              <a:rPr sz="1300" b="0">
+                <a:solidFill>
+                  <a:srgbClr val="6B6B7B"/>
+                </a:solidFill>
+                <a:latin typeface="Segoe UI"/>
+              </a:rPr>
+              <a:t>użytkownik wybiera rok raz — cały raport w tym samym kontekście</a:t>
+            </a:r>
+          </a:p>
+        </p:txBody>
+      </p:sp>
+      <p:sp>
+        <p:nvSpPr>
+          <p:cNvPr id="11" name="Rectangle 10"/>
+          <p:cNvSpPr/>
+          <p:nvPr/>
+        </p:nvSpPr>
+        <p:spPr>
+          <a:xfrm>
+            <a:off x="548640" y="2551176"/>
+            <a:ext cx="329184" cy="329184"/>
+          </a:xfrm>
+          <a:prstGeom prst="rect">
+            <a:avLst/>
+          </a:prstGeom>
+          <a:solidFill>
+            <a:srgbClr val="2E7D32"/>
+          </a:solidFill>
+          <a:ln>
+            <a:noFill/>
+          </a:ln>
+        </p:spPr>
+        <p:style>
+          <a:lnRef idx="1">
+            <a:schemeClr val="accent1"/>
+          </a:lnRef>
+          <a:fillRef idx="3">
+            <a:schemeClr val="accent1"/>
+          </a:fillRef>
+          <a:effectRef idx="2">
+            <a:schemeClr val="accent1"/>
+          </a:effectRef>
+          <a:fontRef idx="minor">
+            <a:schemeClr val="lt1"/>
+          </a:fontRef>
+        </p:style>
+        <p:txBody>
+          <a:bodyPr rtlCol="0" anchor="ctr"/>
+          <a:lstStyle/>
+          <a:p>
+            <a:pPr algn="ctr"/>
+            <a:r>
+              <a:rPr sz="1500" b="1">
+                <a:solidFill>
+                  <a:srgbClr val="FFFFFF"/>
+                </a:solidFill>
+              </a:rPr>
+              <a:t>✔</a:t>
+            </a:r>
+          </a:p>
+        </p:txBody>
+      </p:sp>
+      <p:sp>
+        <p:nvSpPr>
+          <p:cNvPr id="12" name="TextBox 11"/>
+          <p:cNvSpPr txBox="1"/>
+          <p:nvPr/>
+        </p:nvSpPr>
+        <p:spPr>
+          <a:xfrm>
+            <a:off x="1051560" y="2532888"/>
+            <a:ext cx="4480560" cy="457200"/>
+          </a:xfrm>
+          <a:prstGeom prst="rect">
+            <a:avLst/>
+          </a:prstGeom>
+          <a:noFill/>
+        </p:spPr>
+        <p:txBody>
+          <a:bodyPr wrap="square">
+            <a:spAutoFit/>
+          </a:bodyPr>
+          <a:lstStyle/>
+          <a:p>
+            <a:pPr algn="l"/>
+            <a:r>
+              <a:rPr sz="1500" b="1">
+                <a:solidFill>
+                  <a:srgbClr val="1A1A2E"/>
+                </a:solidFill>
+                <a:latin typeface="Segoe UI"/>
+              </a:rPr>
+              <a:t>Drill-down na hierarchiach</a:t>
+            </a:r>
+          </a:p>
+        </p:txBody>
+      </p:sp>
+      <p:sp>
+        <p:nvSpPr>
+          <p:cNvPr id="13" name="TextBox 12"/>
+          <p:cNvSpPr txBox="1"/>
+          <p:nvPr/>
+        </p:nvSpPr>
+        <p:spPr>
+          <a:xfrm>
+            <a:off x="5623560" y="2532888"/>
+            <a:ext cx="6309360" cy="457200"/>
+          </a:xfrm>
+          <a:prstGeom prst="rect">
+            <a:avLst/>
+          </a:prstGeom>
+          <a:noFill/>
+        </p:spPr>
+        <p:txBody>
+          <a:bodyPr wrap="square">
+            <a:spAutoFit/>
+          </a:bodyPr>
+          <a:lstStyle/>
+          <a:p>
+            <a:pPr algn="l"/>
+            <a:r>
+              <a:rPr sz="1300" b="0">
+                <a:solidFill>
+                  <a:srgbClr val="6B6B7B"/>
+                </a:solidFill>
+                <a:latin typeface="Segoe UI"/>
+              </a:rPr>
+              <a:t>macierz kraj→typ; struktura rok→kwartał→miesiąc</a:t>
+            </a:r>
+          </a:p>
+        </p:txBody>
+      </p:sp>
+      <p:sp>
+        <p:nvSpPr>
+          <p:cNvPr id="14" name="Rectangle 13"/>
+          <p:cNvSpPr/>
+          <p:nvPr/>
+        </p:nvSpPr>
+        <p:spPr>
+          <a:xfrm>
+            <a:off x="548640" y="3154680"/>
+            <a:ext cx="329184" cy="329184"/>
+          </a:xfrm>
+          <a:prstGeom prst="rect">
+            <a:avLst/>
+          </a:prstGeom>
+          <a:solidFill>
+            <a:srgbClr val="2E7D32"/>
+          </a:solidFill>
+          <a:ln>
+            <a:noFill/>
+          </a:ln>
+        </p:spPr>
+        <p:style>
+          <a:lnRef idx="1">
+            <a:schemeClr val="accent1"/>
+          </a:lnRef>
+          <a:fillRef idx="3">
+            <a:schemeClr val="accent1"/>
+          </a:fillRef>
+          <a:effectRef idx="2">
+            <a:schemeClr val="accent1"/>
+          </a:effectRef>
+          <a:fontRef idx="minor">
+            <a:schemeClr val="lt1"/>
+          </a:fontRef>
+        </p:style>
+        <p:txBody>
+          <a:bodyPr rtlCol="0" anchor="ctr"/>
+          <a:lstStyle/>
+          <a:p>
+            <a:pPr algn="ctr"/>
+            <a:r>
+              <a:rPr sz="1500" b="1">
+                <a:solidFill>
+                  <a:srgbClr val="FFFFFF"/>
+                </a:solidFill>
+              </a:rPr>
+              <a:t>✔</a:t>
+            </a:r>
+          </a:p>
+        </p:txBody>
+      </p:sp>
+      <p:sp>
+        <p:nvSpPr>
+          <p:cNvPr id="15" name="TextBox 14"/>
+          <p:cNvSpPr txBox="1"/>
+          <p:nvPr/>
+        </p:nvSpPr>
+        <p:spPr>
+          <a:xfrm>
+            <a:off x="1051560" y="3136392"/>
+            <a:ext cx="4480560" cy="457200"/>
+          </a:xfrm>
+          <a:prstGeom prst="rect">
+            <a:avLst/>
+          </a:prstGeom>
+          <a:noFill/>
+        </p:spPr>
+        <p:txBody>
+          <a:bodyPr wrap="square">
+            <a:spAutoFit/>
+          </a:bodyPr>
+          <a:lstStyle/>
+          <a:p>
+            <a:pPr algn="l"/>
+            <a:r>
+              <a:rPr sz="1500" b="1">
+                <a:solidFill>
+                  <a:srgbClr val="1A1A2E"/>
+                </a:solidFill>
+                <a:latin typeface="Segoe UI"/>
+              </a:rPr>
+              <a:t>Miesiące chronologicznie</a:t>
+            </a:r>
+          </a:p>
+        </p:txBody>
+      </p:sp>
+      <p:sp>
+        <p:nvSpPr>
+          <p:cNvPr id="16" name="TextBox 15"/>
+          <p:cNvSpPr txBox="1"/>
+          <p:nvPr/>
+        </p:nvSpPr>
+        <p:spPr>
+          <a:xfrm>
+            <a:off x="5623560" y="3136392"/>
+            <a:ext cx="6309360" cy="457200"/>
+          </a:xfrm>
+          <a:prstGeom prst="rect">
+            <a:avLst/>
+          </a:prstGeom>
+          <a:noFill/>
+        </p:spPr>
+        <p:txBody>
+          <a:bodyPr wrap="square">
+            <a:spAutoFit/>
+          </a:bodyPr>
+          <a:lstStyle/>
+          <a:p>
+            <a:pPr algn="l"/>
+            <a:r>
+              <a:rPr sz="1300" b="0">
+                <a:solidFill>
+                  <a:srgbClr val="6B6B7B"/>
+                </a:solidFill>
+                <a:latin typeface="Segoe UI"/>
+              </a:rPr>
+              <a:t>„sortowanie niechronologiczne to bardzo poważny błąd" (skrypt)</a:t>
+            </a:r>
+          </a:p>
+        </p:txBody>
+      </p:sp>
+      <p:sp>
+        <p:nvSpPr>
+          <p:cNvPr id="17" name="Rectangle 16"/>
+          <p:cNvSpPr/>
+          <p:nvPr/>
+        </p:nvSpPr>
+        <p:spPr>
+          <a:xfrm>
+            <a:off x="548640" y="3758184"/>
+            <a:ext cx="329184" cy="329184"/>
+          </a:xfrm>
+          <a:prstGeom prst="rect">
+            <a:avLst/>
+          </a:prstGeom>
+          <a:solidFill>
+            <a:srgbClr val="2E7D32"/>
+          </a:solidFill>
+          <a:ln>
+            <a:noFill/>
+          </a:ln>
+        </p:spPr>
+        <p:style>
+          <a:lnRef idx="1">
+            <a:schemeClr val="accent1"/>
+          </a:lnRef>
+          <a:fillRef idx="3">
+            <a:schemeClr val="accent1"/>
+          </a:fillRef>
+          <a:effectRef idx="2">
+            <a:schemeClr val="accent1"/>
+          </a:effectRef>
+          <a:fontRef idx="minor">
+            <a:schemeClr val="lt1"/>
+          </a:fontRef>
+        </p:style>
+        <p:txBody>
+          <a:bodyPr rtlCol="0" anchor="ctr"/>
+          <a:lstStyle/>
+          <a:p>
+            <a:pPr algn="ctr"/>
+            <a:r>
+              <a:rPr sz="1500" b="1">
+                <a:solidFill>
+                  <a:srgbClr val="FFFFFF"/>
+                </a:solidFill>
+              </a:rPr>
+              <a:t>✔</a:t>
+            </a:r>
+          </a:p>
+        </p:txBody>
+      </p:sp>
+      <p:sp>
+        <p:nvSpPr>
+          <p:cNvPr id="18" name="TextBox 17"/>
+          <p:cNvSpPr txBox="1"/>
+          <p:nvPr/>
+        </p:nvSpPr>
+        <p:spPr>
+          <a:xfrm>
+            <a:off x="1051560" y="3739896"/>
+            <a:ext cx="4480560" cy="457200"/>
+          </a:xfrm>
+          <a:prstGeom prst="rect">
+            <a:avLst/>
+          </a:prstGeom>
+          <a:noFill/>
+        </p:spPr>
+        <p:txBody>
+          <a:bodyPr wrap="square">
+            <a:spAutoFit/>
+          </a:bodyPr>
+          <a:lstStyle/>
+          <a:p>
+            <a:pPr algn="l"/>
+            <a:r>
+              <a:rPr sz="1500" b="1">
+                <a:solidFill>
+                  <a:srgbClr val="1A1A2E"/>
+                </a:solidFill>
+                <a:latin typeface="Segoe UI"/>
+              </a:rPr>
+              <a:t>Heatmapa = formatowanie warunkowe</a:t>
+            </a:r>
+          </a:p>
+        </p:txBody>
+      </p:sp>
+      <p:sp>
+        <p:nvSpPr>
+          <p:cNvPr id="19" name="TextBox 18"/>
+          <p:cNvSpPr txBox="1"/>
+          <p:nvPr/>
+        </p:nvSpPr>
+        <p:spPr>
+          <a:xfrm>
+            <a:off x="5623560" y="3739896"/>
+            <a:ext cx="6309360" cy="457200"/>
+          </a:xfrm>
+          <a:prstGeom prst="rect">
+            <a:avLst/>
+          </a:prstGeom>
+          <a:noFill/>
+        </p:spPr>
+        <p:txBody>
+          <a:bodyPr wrap="square">
+            <a:spAutoFit/>
+          </a:bodyPr>
+          <a:lstStyle/>
+          <a:p>
+            <a:pPr algn="l"/>
+            <a:r>
+              <a:rPr sz="1300" b="0">
+                <a:solidFill>
+                  <a:srgbClr val="6B6B7B"/>
+                </a:solidFill>
+                <a:latin typeface="Segoe UI"/>
+              </a:rPr>
+              <a:t>oko wychwytuje skalę z koloru, nie z liczb</a:t>
+            </a:r>
+          </a:p>
+        </p:txBody>
+      </p:sp>
+      <p:sp>
+        <p:nvSpPr>
+          <p:cNvPr id="20" name="Rectangle 19"/>
+          <p:cNvSpPr/>
+          <p:nvPr/>
+        </p:nvSpPr>
+        <p:spPr>
+          <a:xfrm>
+            <a:off x="548640" y="4361688"/>
+            <a:ext cx="329184" cy="329184"/>
+          </a:xfrm>
+          <a:prstGeom prst="rect">
+            <a:avLst/>
+          </a:prstGeom>
+          <a:solidFill>
+            <a:srgbClr val="2E7D32"/>
+          </a:solidFill>
+          <a:ln>
+            <a:noFill/>
+          </a:ln>
+        </p:spPr>
+        <p:style>
+          <a:lnRef idx="1">
+            <a:schemeClr val="accent1"/>
+          </a:lnRef>
+          <a:fillRef idx="3">
+            <a:schemeClr val="accent1"/>
+          </a:fillRef>
+          <a:effectRef idx="2">
+            <a:schemeClr val="accent1"/>
+          </a:effectRef>
+          <a:fontRef idx="minor">
+            <a:schemeClr val="lt1"/>
+          </a:fontRef>
+        </p:style>
+        <p:txBody>
+          <a:bodyPr rtlCol="0" anchor="ctr"/>
+          <a:lstStyle/>
+          <a:p>
+            <a:pPr algn="ctr"/>
+            <a:r>
+              <a:rPr sz="1500" b="1">
+                <a:solidFill>
+                  <a:srgbClr val="FFFFFF"/>
+                </a:solidFill>
+              </a:rPr>
+              <a:t>✔</a:t>
+            </a:r>
+          </a:p>
+        </p:txBody>
+      </p:sp>
+      <p:sp>
+        <p:nvSpPr>
+          <p:cNvPr id="21" name="TextBox 20"/>
+          <p:cNvSpPr txBox="1"/>
+          <p:nvPr/>
+        </p:nvSpPr>
+        <p:spPr>
+          <a:xfrm>
+            <a:off x="1051560" y="4343400"/>
+            <a:ext cx="4480560" cy="457200"/>
+          </a:xfrm>
+          <a:prstGeom prst="rect">
+            <a:avLst/>
+          </a:prstGeom>
+          <a:noFill/>
+        </p:spPr>
+        <p:txBody>
+          <a:bodyPr wrap="square">
+            <a:spAutoFit/>
+          </a:bodyPr>
+          <a:lstStyle/>
+          <a:p>
+            <a:pPr algn="l"/>
+            <a:r>
+              <a:rPr sz="1500" b="1">
+                <a:solidFill>
+                  <a:srgbClr val="1A1A2E"/>
+                </a:solidFill>
+                <a:latin typeface="Segoe UI"/>
+              </a:rPr>
+              <a:t>Interakcje między wizualizacjami</a:t>
+            </a:r>
+          </a:p>
+        </p:txBody>
+      </p:sp>
+      <p:sp>
+        <p:nvSpPr>
+          <p:cNvPr id="22" name="TextBox 21"/>
+          <p:cNvSpPr txBox="1"/>
+          <p:nvPr/>
+        </p:nvSpPr>
+        <p:spPr>
+          <a:xfrm>
+            <a:off x="5623560" y="4343400"/>
+            <a:ext cx="6309360" cy="457200"/>
+          </a:xfrm>
+          <a:prstGeom prst="rect">
+            <a:avLst/>
+          </a:prstGeom>
+          <a:noFill/>
+        </p:spPr>
+        <p:txBody>
+          <a:bodyPr wrap="square">
+            <a:spAutoFit/>
+          </a:bodyPr>
+          <a:lstStyle/>
+          <a:p>
+            <a:pPr algn="l"/>
+            <a:r>
+              <a:rPr sz="1300" b="0">
+                <a:solidFill>
+                  <a:srgbClr val="6B6B7B"/>
+                </a:solidFill>
+                <a:latin typeface="Segoe UI"/>
+              </a:rPr>
+              <a:t>klik słupka filtruje sąsiednie wykresy</a:t>
+            </a:r>
+          </a:p>
+        </p:txBody>
+      </p:sp>
+      <p:sp>
+        <p:nvSpPr>
+          <p:cNvPr id="23" name="Rectangle 22"/>
+          <p:cNvSpPr/>
+          <p:nvPr/>
+        </p:nvSpPr>
+        <p:spPr>
+          <a:xfrm>
+            <a:off x="548640" y="4965192"/>
+            <a:ext cx="329184" cy="329184"/>
+          </a:xfrm>
+          <a:prstGeom prst="rect">
+            <a:avLst/>
+          </a:prstGeom>
+          <a:solidFill>
+            <a:srgbClr val="2E7D32"/>
+          </a:solidFill>
+          <a:ln>
+            <a:noFill/>
+          </a:ln>
+        </p:spPr>
+        <p:style>
+          <a:lnRef idx="1">
+            <a:schemeClr val="accent1"/>
+          </a:lnRef>
+          <a:fillRef idx="3">
+            <a:schemeClr val="accent1"/>
+          </a:fillRef>
+          <a:effectRef idx="2">
+            <a:schemeClr val="accent1"/>
+          </a:effectRef>
+          <a:fontRef idx="minor">
+            <a:schemeClr val="lt1"/>
+          </a:fontRef>
+        </p:style>
+        <p:txBody>
+          <a:bodyPr rtlCol="0" anchor="ctr"/>
+          <a:lstStyle/>
+          <a:p>
+            <a:pPr algn="ctr"/>
+            <a:r>
+              <a:rPr sz="1500" b="1">
+                <a:solidFill>
+                  <a:srgbClr val="FFFFFF"/>
+                </a:solidFill>
+              </a:rPr>
+              <a:t>✔</a:t>
+            </a:r>
+          </a:p>
+        </p:txBody>
+      </p:sp>
+      <p:sp>
+        <p:nvSpPr>
+          <p:cNvPr id="24" name="TextBox 23"/>
+          <p:cNvSpPr txBox="1"/>
+          <p:nvPr/>
+        </p:nvSpPr>
+        <p:spPr>
+          <a:xfrm>
+            <a:off x="1051560" y="4946904"/>
+            <a:ext cx="4480560" cy="457200"/>
+          </a:xfrm>
+          <a:prstGeom prst="rect">
+            <a:avLst/>
+          </a:prstGeom>
+          <a:noFill/>
+        </p:spPr>
+        <p:txBody>
+          <a:bodyPr wrap="square">
+            <a:spAutoFit/>
+          </a:bodyPr>
+          <a:lstStyle/>
+          <a:p>
+            <a:pPr algn="l"/>
+            <a:r>
+              <a:rPr sz="1500" b="1">
+                <a:solidFill>
+                  <a:srgbClr val="1A1A2E"/>
+                </a:solidFill>
+                <a:latin typeface="Segoe UI"/>
+              </a:rPr>
+              <a:t>Filtry projektanckie</a:t>
+            </a:r>
+          </a:p>
+        </p:txBody>
+      </p:sp>
+      <p:sp>
+        <p:nvSpPr>
+          <p:cNvPr id="25" name="TextBox 24"/>
+          <p:cNvSpPr txBox="1"/>
+          <p:nvPr/>
+        </p:nvSpPr>
+        <p:spPr>
+          <a:xfrm>
+            <a:off x="5623560" y="4946904"/>
+            <a:ext cx="6309360" cy="457200"/>
+          </a:xfrm>
+          <a:prstGeom prst="rect">
+            <a:avLst/>
+          </a:prstGeom>
+          <a:noFill/>
+        </p:spPr>
+        <p:txBody>
+          <a:bodyPr wrap="square">
+            <a:spAutoFit/>
+          </a:bodyPr>
+          <a:lstStyle/>
+          <a:p>
+            <a:pPr algn="l"/>
+            <a:r>
+              <a:rPr sz="1300" b="0">
+                <a:solidFill>
+                  <a:srgbClr val="6B6B7B"/>
+                </a:solidFill>
+                <a:latin typeface="Segoe UI"/>
+              </a:rPr>
+              <a:t>rok ≤2024 (źródło niepełne za 2025), progi min. zdarzeń w rankingach</a:t>
+            </a:r>
+          </a:p>
+        </p:txBody>
+      </p:sp>
+      <p:sp>
+        <p:nvSpPr>
+          <p:cNvPr id="26" name="Rectangle 25"/>
+          <p:cNvSpPr/>
+          <p:nvPr/>
+        </p:nvSpPr>
+        <p:spPr>
+          <a:xfrm>
+            <a:off x="548640" y="5568696"/>
+            <a:ext cx="329184" cy="329184"/>
+          </a:xfrm>
+          <a:prstGeom prst="rect">
+            <a:avLst/>
+          </a:prstGeom>
+          <a:solidFill>
+            <a:srgbClr val="2E7D32"/>
+          </a:solidFill>
+          <a:ln>
+            <a:noFill/>
+          </a:ln>
+        </p:spPr>
+        <p:style>
+          <a:lnRef idx="1">
+            <a:schemeClr val="accent1"/>
+          </a:lnRef>
+          <a:fillRef idx="3">
+            <a:schemeClr val="accent1"/>
+          </a:fillRef>
+          <a:effectRef idx="2">
+            <a:schemeClr val="accent1"/>
+          </a:effectRef>
+          <a:fontRef idx="minor">
+            <a:schemeClr val="lt1"/>
+          </a:fontRef>
+        </p:style>
+        <p:txBody>
+          <a:bodyPr rtlCol="0" anchor="ctr"/>
+          <a:lstStyle/>
+          <a:p>
+            <a:pPr algn="ctr"/>
+            <a:r>
+              <a:rPr sz="1500" b="1">
+                <a:solidFill>
+                  <a:srgbClr val="FFFFFF"/>
+                </a:solidFill>
+              </a:rPr>
+              <a:t>✔</a:t>
+            </a:r>
+          </a:p>
+        </p:txBody>
+      </p:sp>
+      <p:sp>
+        <p:nvSpPr>
+          <p:cNvPr id="27" name="TextBox 26"/>
+          <p:cNvSpPr txBox="1"/>
+          <p:nvPr/>
+        </p:nvSpPr>
+        <p:spPr>
+          <a:xfrm>
+            <a:off x="1051560" y="5550408"/>
+            <a:ext cx="4480560" cy="457200"/>
+          </a:xfrm>
+          <a:prstGeom prst="rect">
+            <a:avLst/>
+          </a:prstGeom>
+          <a:noFill/>
+        </p:spPr>
+        <p:txBody>
+          <a:bodyPr wrap="square">
+            <a:spAutoFit/>
+          </a:bodyPr>
+          <a:lstStyle/>
+          <a:p>
+            <a:pPr algn="l"/>
+            <a:r>
+              <a:rPr sz="1500" b="1">
+                <a:solidFill>
+                  <a:srgbClr val="1A1A2E"/>
+                </a:solidFill>
+                <a:latin typeface="Segoe UI"/>
+              </a:rPr>
+              <a:t>Zasady wykresów (wykład 8)</a:t>
+            </a:r>
+          </a:p>
+        </p:txBody>
+      </p:sp>
+      <p:sp>
+        <p:nvSpPr>
+          <p:cNvPr id="28" name="TextBox 27"/>
+          <p:cNvSpPr txBox="1"/>
+          <p:nvPr/>
+        </p:nvSpPr>
+        <p:spPr>
+          <a:xfrm>
+            <a:off x="5623560" y="5550408"/>
+            <a:ext cx="6309360" cy="457200"/>
+          </a:xfrm>
+          <a:prstGeom prst="rect">
+            <a:avLst/>
+          </a:prstGeom>
+          <a:noFill/>
+        </p:spPr>
+        <p:txBody>
+          <a:bodyPr wrap="square">
+            <a:spAutoFit/>
+          </a:bodyPr>
+          <a:lstStyle/>
+          <a:p>
+            <a:pPr algn="l"/>
+            <a:r>
+              <a:rPr sz="1300" b="0">
+                <a:solidFill>
+                  <a:srgbClr val="6B6B7B"/>
+                </a:solidFill>
+                <a:latin typeface="Segoe UI"/>
+              </a:rPr>
+              <a:t>słupki od zera, bez 3D, tabela gdy czytamy wartości, tytuły z założeniami</a:t>
+            </a:r>
+          </a:p>
+        </p:txBody>
+      </p:sp>
+    </p:spTree>
+  </p:cSld>
+  <p:clrMapOvr>
+    <a:masterClrMapping/>
+  </p:clrMapOvr>
+</p:sld>
+</file>
+
+<file path=ppt/slides/slide15.xml><?xml version="1.0" encoding="utf-8"?>
+<p:sld xmlns:a="http://schemas.openxmlformats.org/drawingml/2006/main" xmlns:p="http://schemas.openxmlformats.org/presentationml/2006/main" xmlns:r="http://schemas.openxmlformats.org/officeDocument/2006/relationships">
+  <p:cSld>
+    <p:bg>
+      <p:bgPr>
+        <a:solidFill>
+          <a:srgbClr val="F7F7F5"/>
+        </a:solidFill>
+        <a:effectLst/>
+      </p:bgPr>
+    </p:bg>
+    <p:spTree>
+      <p:nvGrpSpPr>
+        <p:cNvPr id="1" name=""/>
+        <p:cNvGrpSpPr/>
+        <p:nvPr/>
+      </p:nvGrpSpPr>
+      <p:grpSpPr/>
+      <p:sp>
+        <p:nvSpPr>
+          <p:cNvPr id="2" name="Rectangle 1"/>
+          <p:cNvSpPr/>
+          <p:nvPr/>
+        </p:nvSpPr>
+        <p:spPr>
+          <a:xfrm>
+            <a:off x="0" y="0"/>
+            <a:ext cx="12191695" cy="164592"/>
+          </a:xfrm>
+          <a:prstGeom prst="rect">
+            <a:avLst/>
+          </a:prstGeom>
+          <a:solidFill>
+            <a:srgbClr val="1F6F8B"/>
+          </a:solidFill>
+          <a:ln>
+            <a:noFill/>
+          </a:ln>
+        </p:spPr>
+        <p:style>
+          <a:lnRef idx="1">
+            <a:schemeClr val="accent1"/>
+          </a:lnRef>
+          <a:fillRef idx="3">
+            <a:schemeClr val="accent1"/>
+          </a:fillRef>
+          <a:effectRef idx="2">
+            <a:schemeClr val="accent1"/>
+          </a:effectRef>
+          <a:fontRef idx="minor">
+            <a:schemeClr val="lt1"/>
+          </a:fontRef>
+        </p:style>
+        <p:txBody>
+          <a:bodyPr rtlCol="0" anchor="ctr"/>
+          <a:lstStyle/>
+          <a:p>
+            <a:pPr algn="ctr"/>
+          </a:p>
+        </p:txBody>
+      </p:sp>
+      <p:sp>
+        <p:nvSpPr>
+          <p:cNvPr id="3" name="TextBox 2"/>
+          <p:cNvSpPr txBox="1"/>
+          <p:nvPr/>
+        </p:nvSpPr>
+        <p:spPr>
+          <a:xfrm>
+            <a:off x="457200" y="292608"/>
+            <a:ext cx="8899855" cy="640080"/>
+          </a:xfrm>
+          <a:prstGeom prst="rect">
+            <a:avLst/>
+          </a:prstGeom>
+          <a:noFill/>
+        </p:spPr>
+        <p:txBody>
+          <a:bodyPr wrap="square">
+            <a:spAutoFit/>
+          </a:bodyPr>
+          <a:lstStyle/>
+          <a:p>
+            <a:pPr algn="l"/>
+            <a:r>
+              <a:rPr sz="2800" b="1">
+                <a:solidFill>
+                  <a:srgbClr val="1F6F8B"/>
+                </a:solidFill>
+                <a:latin typeface="Segoe UI"/>
+              </a:rPr>
+              <a:t>Pytania, na które prosimy o Pani decyzję</a:t>
+            </a:r>
+          </a:p>
+        </p:txBody>
+      </p:sp>
+      <p:sp>
+        <p:nvSpPr>
+          <p:cNvPr id="4" name="Rectangle 3"/>
+          <p:cNvSpPr/>
+          <p:nvPr/>
+        </p:nvSpPr>
+        <p:spPr>
+          <a:xfrm>
+            <a:off x="9448495" y="292608"/>
+            <a:ext cx="2286000" cy="502920"/>
+          </a:xfrm>
+          <a:prstGeom prst="rect">
+            <a:avLst/>
+          </a:prstGeom>
+          <a:solidFill>
+            <a:srgbClr val="A50F15"/>
+          </a:solidFill>
+          <a:ln>
+            <a:noFill/>
+          </a:ln>
+        </p:spPr>
+        <p:style>
+          <a:lnRef idx="1">
+            <a:schemeClr val="accent1"/>
+          </a:lnRef>
+          <a:fillRef idx="3">
+            <a:schemeClr val="accent1"/>
+          </a:fillRef>
+          <a:effectRef idx="2">
+            <a:schemeClr val="accent1"/>
+          </a:effectRef>
+          <a:fontRef idx="minor">
+            <a:schemeClr val="lt1"/>
+          </a:fontRef>
+        </p:style>
+        <p:txBody>
+          <a:bodyPr rtlCol="0" anchor="ctr"/>
+          <a:lstStyle/>
+          <a:p>
+            <a:pPr algn="ctr"/>
+            <a:r>
+              <a:rPr sz="1500" b="1">
+                <a:solidFill>
+                  <a:srgbClr val="FFFFFF"/>
+                </a:solidFill>
+                <a:latin typeface="Segoe UI"/>
+              </a:rPr>
+              <a:t>FEEDBACK</a:t>
+            </a:r>
+          </a:p>
+        </p:txBody>
+      </p:sp>
+      <p:sp>
+        <p:nvSpPr>
+          <p:cNvPr id="5" name="TextBox 4"/>
+          <p:cNvSpPr txBox="1"/>
+          <p:nvPr/>
+        </p:nvSpPr>
+        <p:spPr>
+          <a:xfrm>
+            <a:off x="548640" y="1280160"/>
+            <a:ext cx="11155680" cy="4937760"/>
+          </a:xfrm>
+          <a:prstGeom prst="rect">
+            <a:avLst/>
+          </a:prstGeom>
+          <a:noFill/>
+        </p:spPr>
+        <p:txBody>
+          <a:bodyPr wrap="square">
+            <a:spAutoFit/>
+          </a:bodyPr>
+          <a:lstStyle/>
+          <a:p>
+            <a:r>
+              <a:rPr sz="1600" b="1">
+                <a:solidFill>
+                  <a:srgbClr val="1A1A2E"/>
+                </a:solidFill>
+                <a:latin typeface="Segoe UI"/>
+              </a:rPr>
+              <a:t>• 1. Czy SCHEMAT GWIAZDY jest poprawny? (prosimy o formalne sprawdzenie)</a:t>
+            </a:r>
+          </a:p>
+          <a:p>
+            <a:r>
+              <a:rPr sz="1600" b="0">
+                <a:solidFill>
+                  <a:srgbClr val="1A1A2E"/>
+                </a:solidFill>
+                <a:latin typeface="Segoe UI"/>
+              </a:rPr>
+              <a:t>• 2. Stack: Airflow + Athena/S3 + Power BI zamiast SSIS/SSAS/SSRS — akceptowalny?</a:t>
+            </a:r>
+          </a:p>
+          <a:p>
+            <a:r>
+              <a:rPr sz="1600" b="0">
+                <a:solidFill>
+                  <a:srgbClr val="1A1A2E"/>
+                </a:solidFill>
+                <a:latin typeface="Segoe UI"/>
+              </a:rPr>
+              <a:t>• 3. event_id_cnty jako wymiar zdegenerowany — dopuszczalny?</a:t>
+            </a:r>
+          </a:p>
+          <a:p>
+            <a:r>
+              <a:rPr sz="1600" b="0">
+                <a:solidFill>
+                  <a:srgbClr val="1A1A2E"/>
+                </a:solidFill>
+                <a:latin typeface="Segoe UI"/>
+              </a:rPr>
+              <a:t>• 4. Klucz iso_year + relacja dwukierunkowa do populacji — czy woli Pani inne rozwiązanie?</a:t>
+            </a:r>
+          </a:p>
+          <a:p>
+            <a:r>
+              <a:rPr sz="1600" b="0">
+                <a:solidFill>
+                  <a:srgbClr val="1A1A2E"/>
+                </a:solidFill>
+                <a:latin typeface="Segoe UI"/>
+              </a:rPr>
+              <a:t>• 5. Historia: SCD typ 1 (nadpisanie) + rejestr usunięć — wystarczające dla tego tematu?</a:t>
+            </a:r>
+          </a:p>
+          <a:p>
+            <a:r>
+              <a:rPr sz="1600" b="0">
+                <a:solidFill>
+                  <a:srgbClr val="1A1A2E"/>
+                </a:solidFill>
+                <a:latin typeface="Segoe UI"/>
+              </a:rPr>
+              <a:t>• 6. Rok 2025 niepełny (embargo źródła 12 mies.) — odcinamy w trendach; słuszne podejście?</a:t>
+            </a:r>
+          </a:p>
+          <a:p>
+            <a:r>
+              <a:rPr sz="1600" b="0">
+                <a:solidFill>
+                  <a:srgbClr val="1A1A2E"/>
+                </a:solidFill>
+                <a:latin typeface="Segoe UI"/>
+              </a:rPr>
+              <a:t>• 7. Per capita: Kosowo bez kodu ISO numeric (0,4% zdarzeń bez populacji) — akceptowalna luka?</a:t>
+            </a:r>
+          </a:p>
+          <a:p>
+            <a:r>
+              <a:rPr sz="1600" b="0">
+                <a:solidFill>
+                  <a:srgbClr val="1A1A2E"/>
+                </a:solidFill>
+                <a:latin typeface="Segoe UI"/>
+              </a:rPr>
+              <a:t>• 8. Q10: „czy więcej źródeł ⇒ więcej zdarzeń" wymaga liczności źródeł per zdarzenie — świadomie poza zakresem; OK?</a:t>
+            </a:r>
+          </a:p>
+        </p:txBody>
+      </p:sp>
+    </p:spTree>
+  </p:cSld>
+  <p:clrMapOvr>
+    <a:masterClrMapping/>
+  </p:clrMapOvr>
+</p:sld>
+</file>
+
+<file path=ppt/slides/slide16.xml><?xml version="1.0" encoding="utf-8"?>
+<p:sld xmlns:a="http://schemas.openxmlformats.org/drawingml/2006/main" xmlns:p="http://schemas.openxmlformats.org/presentationml/2006/main" xmlns:r="http://schemas.openxmlformats.org/officeDocument/2006/relationships">
+  <p:cSld>
+    <p:bg>
+      <p:bgPr>
+        <a:solidFill>
+          <a:srgbClr val="F7F7F5"/>
+        </a:solidFill>
+        <a:effectLst/>
+      </p:bgPr>
+    </p:bg>
+    <p:spTree>
+      <p:nvGrpSpPr>
+        <p:cNvPr id="1" name=""/>
+        <p:cNvGrpSpPr/>
+        <p:nvPr/>
+      </p:nvGrpSpPr>
+      <p:grpSpPr/>
+      <p:sp>
+        <p:nvSpPr>
+          <p:cNvPr id="2" name="Rectangle 1"/>
+          <p:cNvSpPr/>
+          <p:nvPr/>
+        </p:nvSpPr>
+        <p:spPr>
+          <a:xfrm>
+            <a:off x="0" y="0"/>
+            <a:ext cx="12191695" cy="164592"/>
+          </a:xfrm>
+          <a:prstGeom prst="rect">
+            <a:avLst/>
+          </a:prstGeom>
+          <a:solidFill>
+            <a:srgbClr val="1F6F8B"/>
+          </a:solidFill>
+          <a:ln>
+            <a:noFill/>
+          </a:ln>
+        </p:spPr>
+        <p:style>
+          <a:lnRef idx="1">
+            <a:schemeClr val="accent1"/>
+          </a:lnRef>
+          <a:fillRef idx="3">
+            <a:schemeClr val="accent1"/>
+          </a:fillRef>
+          <a:effectRef idx="2">
+            <a:schemeClr val="accent1"/>
+          </a:effectRef>
+          <a:fontRef idx="minor">
+            <a:schemeClr val="lt1"/>
+          </a:fontRef>
+        </p:style>
+        <p:txBody>
+          <a:bodyPr rtlCol="0" anchor="ctr"/>
+          <a:lstStyle/>
+          <a:p>
+            <a:pPr algn="ctr"/>
+          </a:p>
+        </p:txBody>
+      </p:sp>
+      <p:sp>
+        <p:nvSpPr>
+          <p:cNvPr id="3" name="TextBox 2"/>
+          <p:cNvSpPr txBox="1"/>
+          <p:nvPr/>
+        </p:nvSpPr>
+        <p:spPr>
+          <a:xfrm>
+            <a:off x="457200" y="292608"/>
+            <a:ext cx="8899855" cy="640080"/>
+          </a:xfrm>
+          <a:prstGeom prst="rect">
+            <a:avLst/>
+          </a:prstGeom>
+          <a:noFill/>
+        </p:spPr>
+        <p:txBody>
+          <a:bodyPr wrap="square">
+            <a:spAutoFit/>
+          </a:bodyPr>
+          <a:lstStyle/>
+          <a:p>
+            <a:pPr algn="l"/>
+            <a:r>
+              <a:rPr sz="2800" b="1">
+                <a:solidFill>
+                  <a:srgbClr val="1F6F8B"/>
+                </a:solidFill>
+                <a:latin typeface="Segoe UI"/>
+              </a:rPr>
+              <a:t>Podsumowanie</a:t>
+            </a:r>
+          </a:p>
+        </p:txBody>
+      </p:sp>
+      <p:sp>
+        <p:nvSpPr>
+          <p:cNvPr id="4" name="TextBox 3"/>
+          <p:cNvSpPr txBox="1"/>
+          <p:nvPr/>
+        </p:nvSpPr>
+        <p:spPr>
+          <a:xfrm>
+            <a:off x="548640" y="1371600"/>
+            <a:ext cx="11155680" cy="3108960"/>
+          </a:xfrm>
+          <a:prstGeom prst="rect">
+            <a:avLst/>
+          </a:prstGeom>
+          <a:noFill/>
+        </p:spPr>
+        <p:txBody>
+          <a:bodyPr wrap="square">
+            <a:spAutoFit/>
+          </a:bodyPr>
+          <a:lstStyle/>
+          <a:p>
+            <a:r>
+              <a:rPr sz="1800" b="1">
+                <a:solidFill>
+                  <a:srgbClr val="1A1A2E"/>
+                </a:solidFill>
+                <a:latin typeface="Segoe UI"/>
+              </a:rPr>
+              <a:t>• Wszystkie punktowane wymagania zrealizowane: pytania · gwiazda · ETL live · semantyka · raporty</a:t>
+            </a:r>
+          </a:p>
+          <a:p>
+            <a:r>
+              <a:rPr sz="1800" b="0">
+                <a:solidFill>
+                  <a:srgbClr val="1A1A2E"/>
+                </a:solidFill>
+                <a:latin typeface="Segoe UI"/>
+              </a:rPr>
+              <a:t>• Dodatkowo: tabela mapowań, screeny ładowań, dokumentacja, 12 naprawionych błędów jakości danych</a:t>
+            </a:r>
+          </a:p>
+          <a:p>
+            <a:r>
+              <a:rPr sz="1800" b="0">
+                <a:solidFill>
+                  <a:srgbClr val="1A1A2E"/>
+                </a:solidFill>
+                <a:latin typeface="Segoe UI"/>
+              </a:rPr>
+              <a:t>• Całość w repozytorium: kod, SQL, DAG-i, model PBI jako kod (TMDL), diagramy, dowody</a:t>
+            </a:r>
+          </a:p>
+        </p:txBody>
+      </p:sp>
+      <p:sp>
+        <p:nvSpPr>
+          <p:cNvPr id="5" name="TextBox 4"/>
+          <p:cNvSpPr txBox="1"/>
+          <p:nvPr/>
+        </p:nvSpPr>
+        <p:spPr>
+          <a:xfrm>
+            <a:off x="548640" y="4754880"/>
+            <a:ext cx="10972800" cy="914400"/>
+          </a:xfrm>
+          <a:prstGeom prst="rect">
+            <a:avLst/>
+          </a:prstGeom>
+          <a:noFill/>
+        </p:spPr>
+        <p:txBody>
+          <a:bodyPr wrap="square">
+            <a:spAutoFit/>
+          </a:bodyPr>
+          <a:lstStyle/>
+          <a:p>
+            <a:pPr algn="l"/>
+            <a:r>
               <a:rPr sz="2000" b="1">
                 <a:solidFill>
                   <a:srgbClr val="1F6F8B"/>
                 </a:solidFill>
                 <a:latin typeface="Segoe UI"/>
               </a:rPr>
-              <a:t>Chętnie pokażemy wszystko na żywo (Airflow / Athena / Power BI)</a:t>
+              <a:t>Chętnie pokażemy wszystko na żywo (Airflow / Athena / Power BI).</a:t>
             </a:r>
           </a:p>
           <a:p>
@@ -4847,7 +6345,7 @@
                 </a:solidFill>
                 <a:latin typeface="Segoe UI"/>
               </a:rPr>
-              <a:t>i prosimy o wskazanie, co poprawić przed oddaniem.</a:t>
+              <a:t>Prosimy o wskazanie poprawek — chcemy je nanieść przed oceną końcową.</a:t>
             </a:r>
           </a:p>
         </p:txBody>
@@ -4951,21 +6449,124 @@
                 </a:solidFill>
                 <a:latin typeface="Segoe UI"/>
               </a:rPr>
-              <a:t>Mapa wymagań — co pokażemy po kolei</a:t>
-            </a:r>
-          </a:p>
-        </p:txBody>
-      </p:sp>
-      <p:sp>
-        <p:nvSpPr>
-          <p:cNvPr id="4" name="TextBox 3"/>
+              <a:t>Status wymagań — komplet zrealizowany</a:t>
+            </a:r>
+          </a:p>
+        </p:txBody>
+      </p:sp>
+      <p:sp>
+        <p:nvSpPr>
+          <p:cNvPr id="4" name="Rectangle 3"/>
+          <p:cNvSpPr/>
+          <p:nvPr/>
+        </p:nvSpPr>
+        <p:spPr>
+          <a:xfrm>
+            <a:off x="9448495" y="292608"/>
+            <a:ext cx="2286000" cy="502920"/>
+          </a:xfrm>
+          <a:prstGeom prst="rect">
+            <a:avLst/>
+          </a:prstGeom>
+          <a:solidFill>
+            <a:srgbClr val="2E7D32"/>
+          </a:solidFill>
+          <a:ln>
+            <a:noFill/>
+          </a:ln>
+        </p:spPr>
+        <p:style>
+          <a:lnRef idx="1">
+            <a:schemeClr val="accent1"/>
+          </a:lnRef>
+          <a:fillRef idx="3">
+            <a:schemeClr val="accent1"/>
+          </a:fillRef>
+          <a:effectRef idx="2">
+            <a:schemeClr val="accent1"/>
+          </a:effectRef>
+          <a:fontRef idx="minor">
+            <a:schemeClr val="lt1"/>
+          </a:fontRef>
+        </p:style>
+        <p:txBody>
+          <a:bodyPr rtlCol="0" anchor="ctr"/>
+          <a:lstStyle/>
+          <a:p>
+            <a:pPr algn="ctr"/>
+            <a:r>
+              <a:rPr sz="1500" b="1">
+                <a:solidFill>
+                  <a:srgbClr val="FFFFFF"/>
+                </a:solidFill>
+                <a:latin typeface="Segoe UI"/>
+              </a:rPr>
+              <a:t>5+5+20+10+10</a:t>
+            </a:r>
+          </a:p>
+        </p:txBody>
+      </p:sp>
+      <p:sp>
+        <p:nvSpPr>
+          <p:cNvPr id="5" name="Rectangle 4"/>
+          <p:cNvSpPr/>
+          <p:nvPr/>
+        </p:nvSpPr>
+        <p:spPr>
+          <a:xfrm>
+            <a:off x="548640" y="1353312"/>
+            <a:ext cx="384048" cy="384048"/>
+          </a:xfrm>
+          <a:prstGeom prst="rect">
+            <a:avLst/>
+          </a:prstGeom>
+          <a:solidFill>
+            <a:srgbClr val="2E7D32"/>
+          </a:solidFill>
+          <a:ln>
+            <a:noFill/>
+          </a:ln>
+        </p:spPr>
+        <p:style>
+          <a:lnRef idx="1">
+            <a:schemeClr val="accent1"/>
+          </a:lnRef>
+          <a:fillRef idx="3">
+            <a:schemeClr val="accent1"/>
+          </a:fillRef>
+          <a:effectRef idx="2">
+            <a:schemeClr val="accent1"/>
+          </a:effectRef>
+          <a:fontRef idx="minor">
+            <a:schemeClr val="lt1"/>
+          </a:fontRef>
+        </p:style>
+        <p:txBody>
+          <a:bodyPr rtlCol="0" anchor="ctr"/>
+          <a:lstStyle/>
+          <a:p>
+            <a:pPr algn="ctr"/>
+            <a:r>
+              <a:rPr sz="1800" b="1">
+                <a:solidFill>
+                  <a:srgbClr val="FFFFFF"/>
+                </a:solidFill>
+              </a:rPr>
+              <a:t>✔</a:t>
+            </a:r>
+          </a:p>
+        </p:txBody>
+      </p:sp>
+      <p:sp>
+        <p:nvSpPr>
+          <p:cNvPr id="6" name="TextBox 5"/>
           <p:cNvSpPr txBox="1"/>
           <p:nvPr/>
         </p:nvSpPr>
         <p:spPr>
           <a:xfrm>
-            <a:off x="548640" y="1371600"/>
-            <a:ext cx="4206240" cy="457200"/>
+            <a:off x="1143000" y="1325880"/>
+            <a:ext cx="4297680" cy="457200"/>
           </a:xfrm>
           <a:prstGeom prst="rect">
             <a:avLst/>
@@ -4986,21 +6587,21 @@
                 </a:solidFill>
                 <a:latin typeface="Segoe UI"/>
               </a:rPr>
-              <a:t>1. Pytania biznesowe (7–12)</a:t>
-            </a:r>
-          </a:p>
-        </p:txBody>
-      </p:sp>
-      <p:sp>
-        <p:nvSpPr>
-          <p:cNvPr id="5" name="TextBox 4"/>
+              <a:t>Pytania biznesowe (5 pkt)</a:t>
+            </a:r>
+          </a:p>
+        </p:txBody>
+      </p:sp>
+      <p:sp>
+        <p:nvSpPr>
+          <p:cNvPr id="7" name="TextBox 6"/>
           <p:cNvSpPr txBox="1"/>
           <p:nvPr/>
         </p:nvSpPr>
         <p:spPr>
           <a:xfrm>
-            <a:off x="4846320" y="1371600"/>
-            <a:ext cx="5486400" cy="457200"/>
+            <a:off x="5532120" y="1325880"/>
+            <a:ext cx="6400800" cy="457200"/>
           </a:xfrm>
           <a:prstGeom prst="rect">
             <a:avLst/>
@@ -5015,27 +6616,78 @@
           <a:p>
             <a:pPr algn="l"/>
             <a:r>
-              <a:rPr sz="1500" b="0">
+              <a:rPr sz="1400" b="0">
                 <a:solidFill>
                   <a:srgbClr val="6B6B7B"/>
                 </a:solidFill>
                 <a:latin typeface="Segoe UI"/>
               </a:rPr>
-              <a:t>12 pytań, wszystkie z odpowiedzią w danych</a:t>
-            </a:r>
-          </a:p>
-        </p:txBody>
-      </p:sp>
-      <p:sp>
-        <p:nvSpPr>
-          <p:cNvPr id="6" name="TextBox 5"/>
+              <a:t>12 pytań, każde z odpowiedzią w raporcie</a:t>
+            </a:r>
+          </a:p>
+        </p:txBody>
+      </p:sp>
+      <p:sp>
+        <p:nvSpPr>
+          <p:cNvPr id="8" name="Rectangle 7"/>
+          <p:cNvSpPr/>
+          <p:nvPr/>
+        </p:nvSpPr>
+        <p:spPr>
+          <a:xfrm>
+            <a:off x="548640" y="2020824"/>
+            <a:ext cx="384048" cy="384048"/>
+          </a:xfrm>
+          <a:prstGeom prst="rect">
+            <a:avLst/>
+          </a:prstGeom>
+          <a:solidFill>
+            <a:srgbClr val="2E7D32"/>
+          </a:solidFill>
+          <a:ln>
+            <a:noFill/>
+          </a:ln>
+        </p:spPr>
+        <p:style>
+          <a:lnRef idx="1">
+            <a:schemeClr val="accent1"/>
+          </a:lnRef>
+          <a:fillRef idx="3">
+            <a:schemeClr val="accent1"/>
+          </a:fillRef>
+          <a:effectRef idx="2">
+            <a:schemeClr val="accent1"/>
+          </a:effectRef>
+          <a:fontRef idx="minor">
+            <a:schemeClr val="lt1"/>
+          </a:fontRef>
+        </p:style>
+        <p:txBody>
+          <a:bodyPr rtlCol="0" anchor="ctr"/>
+          <a:lstStyle/>
+          <a:p>
+            <a:pPr algn="ctr"/>
+            <a:r>
+              <a:rPr sz="1800" b="1">
+                <a:solidFill>
+                  <a:srgbClr val="FFFFFF"/>
+                </a:solidFill>
+              </a:rPr>
+              <a:t>✔</a:t>
+            </a:r>
+          </a:p>
+        </p:txBody>
+      </p:sp>
+      <p:sp>
+        <p:nvSpPr>
+          <p:cNvPr id="9" name="TextBox 8"/>
           <p:cNvSpPr txBox="1"/>
           <p:nvPr/>
         </p:nvSpPr>
         <p:spPr>
           <a:xfrm>
-            <a:off x="10424160" y="1371600"/>
-            <a:ext cx="1463040" cy="457200"/>
+            <a:off x="1143000" y="1993392"/>
+            <a:ext cx="4297680" cy="457200"/>
           </a:xfrm>
           <a:prstGeom prst="rect">
             <a:avLst/>
@@ -5050,27 +6702,27 @@
           <a:p>
             <a:pPr algn="l"/>
             <a:r>
-              <a:rPr sz="1400" b="0">
-                <a:solidFill>
-                  <a:srgbClr val="1F6F8B"/>
-                </a:solidFill>
-                <a:latin typeface="Segoe UI"/>
-              </a:rPr>
-              <a:t>slajd 3</a:t>
-            </a:r>
-          </a:p>
-        </p:txBody>
-      </p:sp>
-      <p:sp>
-        <p:nvSpPr>
-          <p:cNvPr id="7" name="TextBox 6"/>
+              <a:rPr sz="1700" b="1">
+                <a:solidFill>
+                  <a:srgbClr val="1A1A2E"/>
+                </a:solidFill>
+                <a:latin typeface="Segoe UI"/>
+              </a:rPr>
+              <a:t>Schemat gwiazdy (5 pkt)</a:t>
+            </a:r>
+          </a:p>
+        </p:txBody>
+      </p:sp>
+      <p:sp>
+        <p:nvSpPr>
+          <p:cNvPr id="10" name="TextBox 9"/>
           <p:cNvSpPr txBox="1"/>
           <p:nvPr/>
         </p:nvSpPr>
         <p:spPr>
           <a:xfrm>
-            <a:off x="548640" y="2029968"/>
-            <a:ext cx="4206240" cy="457200"/>
+            <a:off x="5532120" y="1993392"/>
+            <a:ext cx="6400800" cy="457200"/>
           </a:xfrm>
           <a:prstGeom prst="rect">
             <a:avLst/>
@@ -5085,27 +6737,78 @@
           <a:p>
             <a:pPr algn="l"/>
             <a:r>
-              <a:rPr sz="1700" b="1">
-                <a:solidFill>
-                  <a:srgbClr val="1A1A2E"/>
-                </a:solidFill>
-                <a:latin typeface="Segoe UI"/>
-              </a:rPr>
-              <a:t>2. Schemat gwiazdy</a:t>
-            </a:r>
-          </a:p>
-        </p:txBody>
-      </p:sp>
-      <p:sp>
-        <p:nvSpPr>
-          <p:cNvPr id="8" name="TextBox 7"/>
+              <a:rPr sz="1400" b="0">
+                <a:solidFill>
+                  <a:srgbClr val="6B6B7B"/>
+                </a:solidFill>
+                <a:latin typeface="Segoe UI"/>
+              </a:rPr>
+              <a:t>czysta gwiazda: fakt + 7 wymiarów, klucze sztuczne, 0 sierot</a:t>
+            </a:r>
+          </a:p>
+        </p:txBody>
+      </p:sp>
+      <p:sp>
+        <p:nvSpPr>
+          <p:cNvPr id="11" name="Rectangle 10"/>
+          <p:cNvSpPr/>
+          <p:nvPr/>
+        </p:nvSpPr>
+        <p:spPr>
+          <a:xfrm>
+            <a:off x="548640" y="2688336"/>
+            <a:ext cx="384048" cy="384048"/>
+          </a:xfrm>
+          <a:prstGeom prst="rect">
+            <a:avLst/>
+          </a:prstGeom>
+          <a:solidFill>
+            <a:srgbClr val="2E7D32"/>
+          </a:solidFill>
+          <a:ln>
+            <a:noFill/>
+          </a:ln>
+        </p:spPr>
+        <p:style>
+          <a:lnRef idx="1">
+            <a:schemeClr val="accent1"/>
+          </a:lnRef>
+          <a:fillRef idx="3">
+            <a:schemeClr val="accent1"/>
+          </a:fillRef>
+          <a:effectRef idx="2">
+            <a:schemeClr val="accent1"/>
+          </a:effectRef>
+          <a:fontRef idx="minor">
+            <a:schemeClr val="lt1"/>
+          </a:fontRef>
+        </p:style>
+        <p:txBody>
+          <a:bodyPr rtlCol="0" anchor="ctr"/>
+          <a:lstStyle/>
+          <a:p>
+            <a:pPr algn="ctr"/>
+            <a:r>
+              <a:rPr sz="1800" b="1">
+                <a:solidFill>
+                  <a:srgbClr val="FFFFFF"/>
+                </a:solidFill>
+              </a:rPr>
+              <a:t>✔</a:t>
+            </a:r>
+          </a:p>
+        </p:txBody>
+      </p:sp>
+      <p:sp>
+        <p:nvSpPr>
+          <p:cNvPr id="12" name="TextBox 11"/>
           <p:cNvSpPr txBox="1"/>
           <p:nvPr/>
         </p:nvSpPr>
         <p:spPr>
           <a:xfrm>
-            <a:off x="4846320" y="2029968"/>
-            <a:ext cx="5486400" cy="457200"/>
+            <a:off x="1143000" y="2660904"/>
+            <a:ext cx="4297680" cy="457200"/>
           </a:xfrm>
           <a:prstGeom prst="rect">
             <a:avLst/>
@@ -5120,27 +6823,27 @@
           <a:p>
             <a:pPr algn="l"/>
             <a:r>
-              <a:rPr sz="1500" b="0">
-                <a:solidFill>
-                  <a:srgbClr val="6B6B7B"/>
-                </a:solidFill>
-                <a:latin typeface="Segoe UI"/>
-              </a:rPr>
-              <a:t>czysta gwiazda, klucze sztuczne, 7 wymiarów</a:t>
-            </a:r>
-          </a:p>
-        </p:txBody>
-      </p:sp>
-      <p:sp>
-        <p:nvSpPr>
-          <p:cNvPr id="9" name="TextBox 8"/>
+              <a:rPr sz="1700" b="1">
+                <a:solidFill>
+                  <a:srgbClr val="1A1A2E"/>
+                </a:solidFill>
+                <a:latin typeface="Segoe UI"/>
+              </a:rPr>
+              <a:t>ETL na żywo (20 pkt)</a:t>
+            </a:r>
+          </a:p>
+        </p:txBody>
+      </p:sp>
+      <p:sp>
+        <p:nvSpPr>
+          <p:cNvPr id="13" name="TextBox 12"/>
           <p:cNvSpPr txBox="1"/>
           <p:nvPr/>
         </p:nvSpPr>
         <p:spPr>
           <a:xfrm>
-            <a:off x="10424160" y="2029968"/>
-            <a:ext cx="1463040" cy="457200"/>
+            <a:off x="5532120" y="2660904"/>
+            <a:ext cx="6400800" cy="457200"/>
           </a:xfrm>
           <a:prstGeom prst="rect">
             <a:avLst/>
@@ -5157,25 +6860,76 @@
             <a:r>
               <a:rPr sz="1400" b="0">
                 <a:solidFill>
-                  <a:srgbClr val="1F6F8B"/>
-                </a:solidFill>
-                <a:latin typeface="Segoe UI"/>
-              </a:rPr>
-              <a:t>slajdy 4–5</a:t>
-            </a:r>
-          </a:p>
-        </p:txBody>
-      </p:sp>
-      <p:sp>
-        <p:nvSpPr>
-          <p:cNvPr id="10" name="TextBox 9"/>
+                  <a:srgbClr val="6B6B7B"/>
+                </a:solidFill>
+                <a:latin typeface="Segoe UI"/>
+              </a:rPr>
+              <a:t>Airflow: 2 DAG-i, idempotentne, walidacja automatyczna — demo live</a:t>
+            </a:r>
+          </a:p>
+        </p:txBody>
+      </p:sp>
+      <p:sp>
+        <p:nvSpPr>
+          <p:cNvPr id="14" name="Rectangle 13"/>
+          <p:cNvSpPr/>
+          <p:nvPr/>
+        </p:nvSpPr>
+        <p:spPr>
+          <a:xfrm>
+            <a:off x="548640" y="3355848"/>
+            <a:ext cx="384048" cy="384048"/>
+          </a:xfrm>
+          <a:prstGeom prst="rect">
+            <a:avLst/>
+          </a:prstGeom>
+          <a:solidFill>
+            <a:srgbClr val="2E7D32"/>
+          </a:solidFill>
+          <a:ln>
+            <a:noFill/>
+          </a:ln>
+        </p:spPr>
+        <p:style>
+          <a:lnRef idx="1">
+            <a:schemeClr val="accent1"/>
+          </a:lnRef>
+          <a:fillRef idx="3">
+            <a:schemeClr val="accent1"/>
+          </a:fillRef>
+          <a:effectRef idx="2">
+            <a:schemeClr val="accent1"/>
+          </a:effectRef>
+          <a:fontRef idx="minor">
+            <a:schemeClr val="lt1"/>
+          </a:fontRef>
+        </p:style>
+        <p:txBody>
+          <a:bodyPr rtlCol="0" anchor="ctr"/>
+          <a:lstStyle/>
+          <a:p>
+            <a:pPr algn="ctr"/>
+            <a:r>
+              <a:rPr sz="1800" b="1">
+                <a:solidFill>
+                  <a:srgbClr val="FFFFFF"/>
+                </a:solidFill>
+              </a:rPr>
+              <a:t>✔</a:t>
+            </a:r>
+          </a:p>
+        </p:txBody>
+      </p:sp>
+      <p:sp>
+        <p:nvSpPr>
+          <p:cNvPr id="15" name="TextBox 14"/>
           <p:cNvSpPr txBox="1"/>
           <p:nvPr/>
         </p:nvSpPr>
         <p:spPr>
           <a:xfrm>
-            <a:off x="548640" y="2688336"/>
-            <a:ext cx="4206240" cy="457200"/>
+            <a:off x="1143000" y="3328416"/>
+            <a:ext cx="4297680" cy="457200"/>
           </a:xfrm>
           <a:prstGeom prst="rect">
             <a:avLst/>
@@ -5196,21 +6950,21 @@
                 </a:solidFill>
                 <a:latin typeface="Segoe UI"/>
               </a:rPr>
-              <a:t>3. ETL uruchomiony na żywo</a:t>
-            </a:r>
-          </a:p>
-        </p:txBody>
-      </p:sp>
-      <p:sp>
-        <p:nvSpPr>
-          <p:cNvPr id="11" name="TextBox 10"/>
+              <a:t>Warstwa semantyczna (10 pkt)</a:t>
+            </a:r>
+          </a:p>
+        </p:txBody>
+      </p:sp>
+      <p:sp>
+        <p:nvSpPr>
+          <p:cNvPr id="16" name="TextBox 15"/>
           <p:cNvSpPr txBox="1"/>
           <p:nvPr/>
         </p:nvSpPr>
         <p:spPr>
           <a:xfrm>
-            <a:off x="4846320" y="2688336"/>
-            <a:ext cx="5486400" cy="457200"/>
+            <a:off x="5532120" y="3328416"/>
+            <a:ext cx="6400800" cy="457200"/>
           </a:xfrm>
           <a:prstGeom prst="rect">
             <a:avLst/>
@@ -5225,27 +6979,78 @@
           <a:p>
             <a:pPr algn="l"/>
             <a:r>
-              <a:rPr sz="1500" b="0">
+              <a:rPr sz="1400" b="0">
                 <a:solidFill>
                   <a:srgbClr val="6B6B7B"/>
                 </a:solidFill>
                 <a:latin typeface="Segoe UI"/>
               </a:rPr>
-              <a:t>Airflow + Glue + Athena, idempotentny, walidowany</a:t>
-            </a:r>
-          </a:p>
-        </p:txBody>
-      </p:sp>
-      <p:sp>
-        <p:nvSpPr>
-          <p:cNvPr id="12" name="TextBox 11"/>
+              <a:t>model Power BI: 7 relacji, 15+ miar DAX, hierarchie, tabela dat</a:t>
+            </a:r>
+          </a:p>
+        </p:txBody>
+      </p:sp>
+      <p:sp>
+        <p:nvSpPr>
+          <p:cNvPr id="17" name="Rectangle 16"/>
+          <p:cNvSpPr/>
+          <p:nvPr/>
+        </p:nvSpPr>
+        <p:spPr>
+          <a:xfrm>
+            <a:off x="548640" y="4023360"/>
+            <a:ext cx="384048" cy="384048"/>
+          </a:xfrm>
+          <a:prstGeom prst="rect">
+            <a:avLst/>
+          </a:prstGeom>
+          <a:solidFill>
+            <a:srgbClr val="2E7D32"/>
+          </a:solidFill>
+          <a:ln>
+            <a:noFill/>
+          </a:ln>
+        </p:spPr>
+        <p:style>
+          <a:lnRef idx="1">
+            <a:schemeClr val="accent1"/>
+          </a:lnRef>
+          <a:fillRef idx="3">
+            <a:schemeClr val="accent1"/>
+          </a:fillRef>
+          <a:effectRef idx="2">
+            <a:schemeClr val="accent1"/>
+          </a:effectRef>
+          <a:fontRef idx="minor">
+            <a:schemeClr val="lt1"/>
+          </a:fontRef>
+        </p:style>
+        <p:txBody>
+          <a:bodyPr rtlCol="0" anchor="ctr"/>
+          <a:lstStyle/>
+          <a:p>
+            <a:pPr algn="ctr"/>
+            <a:r>
+              <a:rPr sz="1800" b="1">
+                <a:solidFill>
+                  <a:srgbClr val="FFFFFF"/>
+                </a:solidFill>
+              </a:rPr>
+              <a:t>✔</a:t>
+            </a:r>
+          </a:p>
+        </p:txBody>
+      </p:sp>
+      <p:sp>
+        <p:nvSpPr>
+          <p:cNvPr id="18" name="TextBox 17"/>
           <p:cNvSpPr txBox="1"/>
           <p:nvPr/>
         </p:nvSpPr>
         <p:spPr>
           <a:xfrm>
-            <a:off x="10424160" y="2688336"/>
-            <a:ext cx="1463040" cy="457200"/>
+            <a:off x="1143000" y="3995928"/>
+            <a:ext cx="4297680" cy="457200"/>
           </a:xfrm>
           <a:prstGeom prst="rect">
             <a:avLst/>
@@ -5260,27 +7065,27 @@
           <a:p>
             <a:pPr algn="l"/>
             <a:r>
-              <a:rPr sz="1400" b="0">
-                <a:solidFill>
-                  <a:srgbClr val="1F6F8B"/>
-                </a:solidFill>
-                <a:latin typeface="Segoe UI"/>
-              </a:rPr>
-              <a:t>slajdy 6–9</a:t>
-            </a:r>
-          </a:p>
-        </p:txBody>
-      </p:sp>
-      <p:sp>
-        <p:nvSpPr>
-          <p:cNvPr id="13" name="TextBox 12"/>
+              <a:rPr sz="1700" b="1">
+                <a:solidFill>
+                  <a:srgbClr val="1A1A2E"/>
+                </a:solidFill>
+                <a:latin typeface="Segoe UI"/>
+              </a:rPr>
+              <a:t>Raporty z wykresami (10 pkt)</a:t>
+            </a:r>
+          </a:p>
+        </p:txBody>
+      </p:sp>
+      <p:sp>
+        <p:nvSpPr>
+          <p:cNvPr id="19" name="TextBox 18"/>
           <p:cNvSpPr txBox="1"/>
           <p:nvPr/>
         </p:nvSpPr>
         <p:spPr>
           <a:xfrm>
-            <a:off x="548640" y="3346704"/>
-            <a:ext cx="4206240" cy="457200"/>
+            <a:off x="5532120" y="3995928"/>
+            <a:ext cx="6400800" cy="457200"/>
           </a:xfrm>
           <a:prstGeom prst="rect">
             <a:avLst/>
@@ -5295,27 +7100,78 @@
           <a:p>
             <a:pPr algn="l"/>
             <a:r>
-              <a:rPr sz="1700" b="1">
-                <a:solidFill>
-                  <a:srgbClr val="1A1A2E"/>
-                </a:solidFill>
-                <a:latin typeface="Segoe UI"/>
-              </a:rPr>
-              <a:t>4. Warstwa semantyczna</a:t>
-            </a:r>
-          </a:p>
-        </p:txBody>
-      </p:sp>
-      <p:sp>
-        <p:nvSpPr>
-          <p:cNvPr id="14" name="TextBox 13"/>
+              <a:rPr sz="1400" b="0">
+                <a:solidFill>
+                  <a:srgbClr val="6B6B7B"/>
+                </a:solidFill>
+                <a:latin typeface="Segoe UI"/>
+              </a:rPr>
+              <a:t>9 stron: dashboard + strona per pytanie, slicery, drill-down</a:t>
+            </a:r>
+          </a:p>
+        </p:txBody>
+      </p:sp>
+      <p:sp>
+        <p:nvSpPr>
+          <p:cNvPr id="20" name="Rectangle 19"/>
+          <p:cNvSpPr/>
+          <p:nvPr/>
+        </p:nvSpPr>
+        <p:spPr>
+          <a:xfrm>
+            <a:off x="548640" y="4690872"/>
+            <a:ext cx="384048" cy="384048"/>
+          </a:xfrm>
+          <a:prstGeom prst="rect">
+            <a:avLst/>
+          </a:prstGeom>
+          <a:solidFill>
+            <a:srgbClr val="2E7D32"/>
+          </a:solidFill>
+          <a:ln>
+            <a:noFill/>
+          </a:ln>
+        </p:spPr>
+        <p:style>
+          <a:lnRef idx="1">
+            <a:schemeClr val="accent1"/>
+          </a:lnRef>
+          <a:fillRef idx="3">
+            <a:schemeClr val="accent1"/>
+          </a:fillRef>
+          <a:effectRef idx="2">
+            <a:schemeClr val="accent1"/>
+          </a:effectRef>
+          <a:fontRef idx="minor">
+            <a:schemeClr val="lt1"/>
+          </a:fontRef>
+        </p:style>
+        <p:txBody>
+          <a:bodyPr rtlCol="0" anchor="ctr"/>
+          <a:lstStyle/>
+          <a:p>
+            <a:pPr algn="ctr"/>
+            <a:r>
+              <a:rPr sz="1800" b="1">
+                <a:solidFill>
+                  <a:srgbClr val="FFFFFF"/>
+                </a:solidFill>
+              </a:rPr>
+              <a:t>✔</a:t>
+            </a:r>
+          </a:p>
+        </p:txBody>
+      </p:sp>
+      <p:sp>
+        <p:nvSpPr>
+          <p:cNvPr id="21" name="TextBox 20"/>
           <p:cNvSpPr txBox="1"/>
           <p:nvPr/>
         </p:nvSpPr>
         <p:spPr>
           <a:xfrm>
-            <a:off x="4846320" y="3346704"/>
-            <a:ext cx="5486400" cy="457200"/>
+            <a:off x="1143000" y="4663440"/>
+            <a:ext cx="4297680" cy="457200"/>
           </a:xfrm>
           <a:prstGeom prst="rect">
             <a:avLst/>
@@ -5330,27 +7186,27 @@
           <a:p>
             <a:pPr algn="l"/>
             <a:r>
-              <a:rPr sz="1500" b="0">
-                <a:solidFill>
-                  <a:srgbClr val="6B6B7B"/>
-                </a:solidFill>
-                <a:latin typeface="Segoe UI"/>
-              </a:rPr>
-              <a:t>model Power BI: relacje, 15 miar DAX, hierarchie</a:t>
-            </a:r>
-          </a:p>
-        </p:txBody>
-      </p:sp>
-      <p:sp>
-        <p:nvSpPr>
-          <p:cNvPr id="15" name="TextBox 14"/>
+              <a:rPr sz="1700" b="1">
+                <a:solidFill>
+                  <a:srgbClr val="1A1A2E"/>
+                </a:solidFill>
+                <a:latin typeface="Segoe UI"/>
+              </a:rPr>
+              <a:t>Zadanie: tabela mapowań</a:t>
+            </a:r>
+          </a:p>
+        </p:txBody>
+      </p:sp>
+      <p:sp>
+        <p:nvSpPr>
+          <p:cNvPr id="22" name="TextBox 21"/>
           <p:cNvSpPr txBox="1"/>
           <p:nvPr/>
         </p:nvSpPr>
         <p:spPr>
           <a:xfrm>
-            <a:off x="10424160" y="3346704"/>
-            <a:ext cx="1463040" cy="457200"/>
+            <a:off x="5532120" y="4663440"/>
+            <a:ext cx="6400800" cy="457200"/>
           </a:xfrm>
           <a:prstGeom prst="rect">
             <a:avLst/>
@@ -5367,25 +7223,76 @@
             <a:r>
               <a:rPr sz="1400" b="0">
                 <a:solidFill>
-                  <a:srgbClr val="1F6F8B"/>
-                </a:solidFill>
-                <a:latin typeface="Segoe UI"/>
-              </a:rPr>
-              <a:t>slajd 10</a:t>
-            </a:r>
-          </a:p>
-        </p:txBody>
-      </p:sp>
-      <p:sp>
-        <p:nvSpPr>
-          <p:cNvPr id="16" name="TextBox 15"/>
+                  <a:srgbClr val="6B6B7B"/>
+                </a:solidFill>
+                <a:latin typeface="Segoe UI"/>
+              </a:rPr>
+              <a:t>docs/etl_mapowania.md — źródło→transformacja→cel</a:t>
+            </a:r>
+          </a:p>
+        </p:txBody>
+      </p:sp>
+      <p:sp>
+        <p:nvSpPr>
+          <p:cNvPr id="23" name="Rectangle 22"/>
+          <p:cNvSpPr/>
+          <p:nvPr/>
+        </p:nvSpPr>
+        <p:spPr>
+          <a:xfrm>
+            <a:off x="548640" y="5358384"/>
+            <a:ext cx="384048" cy="384048"/>
+          </a:xfrm>
+          <a:prstGeom prst="rect">
+            <a:avLst/>
+          </a:prstGeom>
+          <a:solidFill>
+            <a:srgbClr val="2E7D32"/>
+          </a:solidFill>
+          <a:ln>
+            <a:noFill/>
+          </a:ln>
+        </p:spPr>
+        <p:style>
+          <a:lnRef idx="1">
+            <a:schemeClr val="accent1"/>
+          </a:lnRef>
+          <a:fillRef idx="3">
+            <a:schemeClr val="accent1"/>
+          </a:fillRef>
+          <a:effectRef idx="2">
+            <a:schemeClr val="accent1"/>
+          </a:effectRef>
+          <a:fontRef idx="minor">
+            <a:schemeClr val="lt1"/>
+          </a:fontRef>
+        </p:style>
+        <p:txBody>
+          <a:bodyPr rtlCol="0" anchor="ctr"/>
+          <a:lstStyle/>
+          <a:p>
+            <a:pPr algn="ctr"/>
+            <a:r>
+              <a:rPr sz="1800" b="1">
+                <a:solidFill>
+                  <a:srgbClr val="FFFFFF"/>
+                </a:solidFill>
+              </a:rPr>
+              <a:t>✔</a:t>
+            </a:r>
+          </a:p>
+        </p:txBody>
+      </p:sp>
+      <p:sp>
+        <p:nvSpPr>
+          <p:cNvPr id="24" name="TextBox 23"/>
           <p:cNvSpPr txBox="1"/>
           <p:nvPr/>
         </p:nvSpPr>
         <p:spPr>
           <a:xfrm>
-            <a:off x="548640" y="4005072"/>
-            <a:ext cx="4206240" cy="457200"/>
+            <a:off x="1143000" y="5330952"/>
+            <a:ext cx="4297680" cy="457200"/>
           </a:xfrm>
           <a:prstGeom prst="rect">
             <a:avLst/>
@@ -5406,21 +7313,21 @@
                 </a:solidFill>
                 <a:latin typeface="Segoe UI"/>
               </a:rPr>
-              <a:t>5. Raporty z wykresami</a:t>
-            </a:r>
-          </a:p>
-        </p:txBody>
-      </p:sp>
-      <p:sp>
-        <p:nvSpPr>
-          <p:cNvPr id="17" name="TextBox 16"/>
+              <a:t>Zadanie: screeny ładowań</a:t>
+            </a:r>
+          </a:p>
+        </p:txBody>
+      </p:sp>
+      <p:sp>
+        <p:nvSpPr>
+          <p:cNvPr id="25" name="TextBox 24"/>
           <p:cNvSpPr txBox="1"/>
           <p:nvPr/>
         </p:nvSpPr>
         <p:spPr>
           <a:xfrm>
-            <a:off x="4846320" y="4005072"/>
-            <a:ext cx="5486400" cy="457200"/>
+            <a:off x="5532120" y="5330952"/>
+            <a:ext cx="6400800" cy="457200"/>
           </a:xfrm>
           <a:prstGeom prst="rect">
             <a:avLst/>
@@ -5435,27 +7342,27 @@
           <a:p>
             <a:pPr algn="l"/>
             <a:r>
-              <a:rPr sz="1500" b="0">
+              <a:rPr sz="1400" b="0">
                 <a:solidFill>
                   <a:srgbClr val="6B6B7B"/>
                 </a:solidFill>
                 <a:latin typeface="Segoe UI"/>
               </a:rPr>
-              <a:t>dashboard + strona per pytanie — W TRAKCIE</a:t>
-            </a:r>
-          </a:p>
-        </p:txBody>
-      </p:sp>
-      <p:sp>
-        <p:nvSpPr>
-          <p:cNvPr id="18" name="TextBox 17"/>
+              <a:t>13 zrzutów: każdy wymiar + fakt + walidacja</a:t>
+            </a:r>
+          </a:p>
+        </p:txBody>
+      </p:sp>
+      <p:sp>
+        <p:nvSpPr>
+          <p:cNvPr id="26" name="TextBox 25"/>
           <p:cNvSpPr txBox="1"/>
           <p:nvPr/>
         </p:nvSpPr>
         <p:spPr>
           <a:xfrm>
-            <a:off x="10424160" y="4005072"/>
-            <a:ext cx="1463040" cy="457200"/>
+            <a:off x="548640" y="6108192"/>
+            <a:ext cx="11155680" cy="457200"/>
           </a:xfrm>
           <a:prstGeom prst="rect">
             <a:avLst/>
@@ -5470,258 +7377,13 @@
           <a:p>
             <a:pPr algn="l"/>
             <a:r>
-              <a:rPr sz="1400" b="0">
-                <a:solidFill>
-                  <a:srgbClr val="1F6F8B"/>
-                </a:solidFill>
-                <a:latin typeface="Segoe UI"/>
-              </a:rPr>
-              <a:t>slajd 11</a:t>
-            </a:r>
-          </a:p>
-        </p:txBody>
-      </p:sp>
-      <p:sp>
-        <p:nvSpPr>
-          <p:cNvPr id="19" name="TextBox 18"/>
-          <p:cNvSpPr txBox="1"/>
-          <p:nvPr/>
-        </p:nvSpPr>
-        <p:spPr>
-          <a:xfrm>
-            <a:off x="548640" y="4663440"/>
-            <a:ext cx="4206240" cy="457200"/>
-          </a:xfrm>
-          <a:prstGeom prst="rect">
-            <a:avLst/>
-          </a:prstGeom>
-          <a:noFill/>
-        </p:spPr>
-        <p:txBody>
-          <a:bodyPr wrap="square">
-            <a:spAutoFit/>
-          </a:bodyPr>
-          <a:lstStyle/>
-          <a:p>
-            <a:pPr algn="l"/>
-            <a:r>
-              <a:rPr sz="1700" b="1">
-                <a:solidFill>
-                  <a:srgbClr val="1A1A2E"/>
-                </a:solidFill>
-                <a:latin typeface="Segoe UI"/>
-              </a:rPr>
-              <a:t>Zadanie: tabela mapowań</a:t>
-            </a:r>
-          </a:p>
-        </p:txBody>
-      </p:sp>
-      <p:sp>
-        <p:nvSpPr>
-          <p:cNvPr id="20" name="TextBox 19"/>
-          <p:cNvSpPr txBox="1"/>
-          <p:nvPr/>
-        </p:nvSpPr>
-        <p:spPr>
-          <a:xfrm>
-            <a:off x="4846320" y="4663440"/>
-            <a:ext cx="5486400" cy="457200"/>
-          </a:xfrm>
-          <a:prstGeom prst="rect">
-            <a:avLst/>
-          </a:prstGeom>
-          <a:noFill/>
-        </p:spPr>
-        <p:txBody>
-          <a:bodyPr wrap="square">
-            <a:spAutoFit/>
-          </a:bodyPr>
-          <a:lstStyle/>
-          <a:p>
-            <a:pPr algn="l"/>
-            <a:r>
-              <a:rPr sz="1500" b="0">
-                <a:solidFill>
-                  <a:srgbClr val="6B6B7B"/>
-                </a:solidFill>
-                <a:latin typeface="Segoe UI"/>
-              </a:rPr>
-              <a:t>docs/etl_mapowania.md — etap po etapie</a:t>
-            </a:r>
-          </a:p>
-        </p:txBody>
-      </p:sp>
-      <p:sp>
-        <p:nvSpPr>
-          <p:cNvPr id="21" name="TextBox 20"/>
-          <p:cNvSpPr txBox="1"/>
-          <p:nvPr/>
-        </p:nvSpPr>
-        <p:spPr>
-          <a:xfrm>
-            <a:off x="10424160" y="4663440"/>
-            <a:ext cx="1463040" cy="457200"/>
-          </a:xfrm>
-          <a:prstGeom prst="rect">
-            <a:avLst/>
-          </a:prstGeom>
-          <a:noFill/>
-        </p:spPr>
-        <p:txBody>
-          <a:bodyPr wrap="square">
-            <a:spAutoFit/>
-          </a:bodyPr>
-          <a:lstStyle/>
-          <a:p>
-            <a:pPr algn="l"/>
-            <a:r>
-              <a:rPr sz="1400" b="0">
-                <a:solidFill>
-                  <a:srgbClr val="1F6F8B"/>
-                </a:solidFill>
-                <a:latin typeface="Segoe UI"/>
-              </a:rPr>
-              <a:t>slajd 7</a:t>
-            </a:r>
-          </a:p>
-        </p:txBody>
-      </p:sp>
-      <p:sp>
-        <p:nvSpPr>
-          <p:cNvPr id="22" name="TextBox 21"/>
-          <p:cNvSpPr txBox="1"/>
-          <p:nvPr/>
-        </p:nvSpPr>
-        <p:spPr>
-          <a:xfrm>
-            <a:off x="548640" y="5321808"/>
-            <a:ext cx="4206240" cy="457200"/>
-          </a:xfrm>
-          <a:prstGeom prst="rect">
-            <a:avLst/>
-          </a:prstGeom>
-          <a:noFill/>
-        </p:spPr>
-        <p:txBody>
-          <a:bodyPr wrap="square">
-            <a:spAutoFit/>
-          </a:bodyPr>
-          <a:lstStyle/>
-          <a:p>
-            <a:pPr algn="l"/>
-            <a:r>
-              <a:rPr sz="1700" b="1">
-                <a:solidFill>
-                  <a:srgbClr val="1A1A2E"/>
-                </a:solidFill>
-                <a:latin typeface="Segoe UI"/>
-              </a:rPr>
-              <a:t>Zadanie: screeny ładowań</a:t>
-            </a:r>
-          </a:p>
-        </p:txBody>
-      </p:sp>
-      <p:sp>
-        <p:nvSpPr>
-          <p:cNvPr id="23" name="TextBox 22"/>
-          <p:cNvSpPr txBox="1"/>
-          <p:nvPr/>
-        </p:nvSpPr>
-        <p:spPr>
-          <a:xfrm>
-            <a:off x="4846320" y="5321808"/>
-            <a:ext cx="5486400" cy="457200"/>
-          </a:xfrm>
-          <a:prstGeom prst="rect">
-            <a:avLst/>
-          </a:prstGeom>
-          <a:noFill/>
-        </p:spPr>
-        <p:txBody>
-          <a:bodyPr wrap="square">
-            <a:spAutoFit/>
-          </a:bodyPr>
-          <a:lstStyle/>
-          <a:p>
-            <a:pPr algn="l"/>
-            <a:r>
-              <a:rPr sz="1500" b="0">
-                <a:solidFill>
-                  <a:srgbClr val="6B6B7B"/>
-                </a:solidFill>
-                <a:latin typeface="Segoe UI"/>
-              </a:rPr>
-              <a:t>13 zrzutów: każdy wymiar + fakt + walidacja</a:t>
-            </a:r>
-          </a:p>
-        </p:txBody>
-      </p:sp>
-      <p:sp>
-        <p:nvSpPr>
-          <p:cNvPr id="24" name="TextBox 23"/>
-          <p:cNvSpPr txBox="1"/>
-          <p:nvPr/>
-        </p:nvSpPr>
-        <p:spPr>
-          <a:xfrm>
-            <a:off x="10424160" y="5321808"/>
-            <a:ext cx="1463040" cy="457200"/>
-          </a:xfrm>
-          <a:prstGeom prst="rect">
-            <a:avLst/>
-          </a:prstGeom>
-          <a:noFill/>
-        </p:spPr>
-        <p:txBody>
-          <a:bodyPr wrap="square">
-            <a:spAutoFit/>
-          </a:bodyPr>
-          <a:lstStyle/>
-          <a:p>
-            <a:pPr algn="l"/>
-            <a:r>
-              <a:rPr sz="1400" b="0">
-                <a:solidFill>
-                  <a:srgbClr val="1F6F8B"/>
-                </a:solidFill>
-                <a:latin typeface="Segoe UI"/>
-              </a:rPr>
-              <a:t>slajd 9</a:t>
-            </a:r>
-          </a:p>
-        </p:txBody>
-      </p:sp>
-      <p:sp>
-        <p:nvSpPr>
-          <p:cNvPr id="25" name="TextBox 24"/>
-          <p:cNvSpPr txBox="1"/>
-          <p:nvPr/>
-        </p:nvSpPr>
-        <p:spPr>
-          <a:xfrm>
-            <a:off x="548640" y="6117336"/>
-            <a:ext cx="10972800" cy="457200"/>
-          </a:xfrm>
-          <a:prstGeom prst="rect">
-            <a:avLst/>
-          </a:prstGeom>
-          <a:noFill/>
-        </p:spPr>
-        <p:txBody>
-          <a:bodyPr wrap="square">
-            <a:spAutoFit/>
-          </a:bodyPr>
-          <a:lstStyle/>
-          <a:p>
-            <a:pPr algn="l"/>
-            <a:r>
               <a:rPr sz="1600" b="1">
                 <a:solidFill>
                   <a:srgbClr val="A50F15"/>
                 </a:solidFill>
                 <a:latin typeface="Segoe UI"/>
               </a:rPr>
-              <a:t>Na końcu: lista otwartych pytań, na które potrzebujemy Pani decyzji.</a:t>
+              <a:t>Prosimy o ocenę i wskazanie, co ewentualnie poprawić — lista pytań na końcu.</a:t>
             </a:r>
           </a:p>
         </p:txBody>
@@ -5845,7 +7507,7 @@
             <a:avLst/>
           </a:prstGeom>
           <a:solidFill>
-            <a:srgbClr val="E08E45"/>
+            <a:srgbClr val="2E7D32"/>
           </a:solidFill>
           <a:ln>
             <a:noFill/>
@@ -5877,7 +7539,7 @@
                 </a:solidFill>
                 <a:latin typeface="Segoe UI"/>
               </a:rPr>
-              <a:t>wymóg 1–3</a:t>
+              <a:t>wymóg 1–3 ✔</a:t>
             </a:r>
           </a:p>
         </p:txBody>
@@ -5891,7 +7553,7 @@
         <p:spPr>
           <a:xfrm>
             <a:off x="548640" y="1280160"/>
-            <a:ext cx="5394960" cy="2286000"/>
+            <a:ext cx="5394960" cy="2194560"/>
           </a:xfrm>
           <a:prstGeom prst="rect">
             <a:avLst/>
@@ -5922,7 +7584,18 @@
                 </a:solidFill>
                 <a:latin typeface="Segoe UI"/>
               </a:rPr>
-              <a:t>   – 2 669 294 zdarzeń · 1997–2025 · cały świat</a:t>
+              <a:t>   – 2 669 294 zdarzeń · 1997–2025 · 242 kraje</a:t>
+            </a:r>
+          </a:p>
+          <a:p>
+            <a:r>
+              <a:rPr sz="1300" b="0">
+                <a:solidFill>
+                  <a:srgbClr val="6B6B7B"/>
+                </a:solidFill>
+                <a:latin typeface="Segoe UI"/>
+              </a:rPr>
+              <a:t>   – źródło publikuje z 12-mies. embargiem (znanym z góry)</a:t>
             </a:r>
           </a:p>
           <a:p>
@@ -5933,7 +7606,7 @@
                 </a:solidFill>
                 <a:latin typeface="Segoe UI"/>
               </a:rPr>
-              <a:t>• World Bank SP.POP.TOTL — populacja do per capita</a:t>
+              <a:t>• World Bank SP.POP.TOTL — populacja (per capita)</a:t>
             </a:r>
           </a:p>
           <a:p>
@@ -5957,8 +7630,8 @@
         </p:nvSpPr>
         <p:spPr>
           <a:xfrm>
-            <a:off x="548640" y="3291840"/>
-            <a:ext cx="5577840" cy="3017520"/>
+            <a:off x="548640" y="3383280"/>
+            <a:ext cx="5577840" cy="2926080"/>
           </a:xfrm>
           <a:prstGeom prst="rect">
             <a:avLst/>
@@ -5978,7 +7651,7 @@
                 </a:solidFill>
                 <a:latin typeface="Segoe UI"/>
               </a:rPr>
-              <a:t>• 1. Kraje/regiony z największą liczbą zdarzeń + typy</a:t>
+              <a:t>• 1. Kraje/regiony + dominujące typy</a:t>
             </a:r>
           </a:p>
           <a:p>
@@ -6000,7 +7673,7 @@
                 </a:solidFill>
                 <a:latin typeface="Segoe UI"/>
               </a:rPr>
-              <a:t>• 3. Trend zdarzeń w czasie per typ niepokoju</a:t>
+              <a:t>• 3. Trend per typ niepokoju (rok+miesiąc)</a:t>
             </a:r>
           </a:p>
           <a:p>
@@ -6011,7 +7684,7 @@
                 </a:solidFill>
                 <a:latin typeface="Segoe UI"/>
               </a:rPr>
-              <a:t>• 4. Sezonowość (miesiące)</a:t>
+              <a:t>• 4. Sezonowość (zdarzenia i ofiary)</a:t>
             </a:r>
           </a:p>
           <a:p>
@@ -6022,7 +7695,7 @@
                 </a:solidFill>
                 <a:latin typeface="Segoe UI"/>
               </a:rPr>
-              <a:t>• 5. Najbardziej śmiertelne typy zdarzeń</a:t>
+              <a:t>• 5. Najbardziej śmiertelne typy + średnia</a:t>
             </a:r>
           </a:p>
           <a:p>
@@ -6046,8 +7719,8 @@
         </p:nvSpPr>
         <p:spPr>
           <a:xfrm>
-            <a:off x="6309360" y="3291840"/>
-            <a:ext cx="5577840" cy="3017520"/>
+            <a:off x="6309360" y="3383280"/>
+            <a:ext cx="5577840" cy="2926080"/>
           </a:xfrm>
           <a:prstGeom prst="rect">
             <a:avLst/>
@@ -6078,7 +7751,7 @@
                 </a:solidFill>
                 <a:latin typeface="Segoe UI"/>
               </a:rPr>
-              <a:t>• 8. Interakcje (państwo–rebelianci itd.)</a:t>
+              <a:t>• 8. Interakcje — najczęstsze i najkrwawsze</a:t>
             </a:r>
           </a:p>
           <a:p>
@@ -6089,7 +7762,7 @@
                 </a:solidFill>
                 <a:latin typeface="Segoe UI"/>
               </a:rPr>
-              <a:t>• 9. % celowania w cywilów po regionach/aktorach</a:t>
+              <a:t>• 9. % celowania w cywilów: regiony i aktorzy</a:t>
             </a:r>
           </a:p>
           <a:p>
@@ -6100,7 +7773,7 @@
                 </a:solidFill>
                 <a:latin typeface="Segoe UI"/>
               </a:rPr>
-              <a:t>• 10. Źródła lokalne vs międzynarodowe per region</a:t>
+              <a:t>• 10. Źródła lokalne vs międzynarodowe</a:t>
             </a:r>
           </a:p>
           <a:p>
@@ -6122,7 +7795,7 @@
                 </a:solidFill>
                 <a:latin typeface="Segoe UI"/>
               </a:rPr>
-              <a:t>• 12. Per capita — zmiana rankingu</a:t>
+              <a:t>• 12. Per capita — odwrócenie rankingu</a:t>
             </a:r>
           </a:p>
         </p:txBody>
@@ -6135,7 +7808,7 @@
         </p:nvSpPr>
         <p:spPr>
           <a:xfrm>
-            <a:off x="457200" y="1234440"/>
+            <a:off x="457200" y="1207008"/>
             <a:ext cx="11277295" cy="777240"/>
           </a:xfrm>
           <a:prstGeom prst="rect">
@@ -6176,7 +7849,7 @@
                 </a:solidFill>
                 <a:latin typeface="Segoe UI"/>
               </a:rPr>
-              <a:t>PYTANIE DO PANI:  czy zakres i liczba pytań są wystarczające?</a:t>
+              <a:t>PYTANIE DO PANI:  czy zakres pytań jest wystarczający?</a:t>
             </a:r>
           </a:p>
         </p:txBody>
@@ -6280,7 +7953,7 @@
                 </a:solidFill>
                 <a:latin typeface="Segoe UI"/>
               </a:rPr>
-              <a:t>Schemat gwiazdy — model</a:t>
+              <a:t>Schemat gwiazdy</a:t>
             </a:r>
           </a:p>
         </p:txBody>
@@ -6300,7 +7973,7 @@
             <a:avLst/>
           </a:prstGeom>
           <a:solidFill>
-            <a:srgbClr val="E08E45"/>
+            <a:srgbClr val="2E7D32"/>
           </a:solidFill>
           <a:ln>
             <a:noFill/>
@@ -6332,7 +8005,7 @@
                 </a:solidFill>
                 <a:latin typeface="Segoe UI"/>
               </a:rPr>
-              <a:t>wymóg: gwiazda</a:t>
+              <a:t>wymóg ✔</a:t>
             </a:r>
           </a:p>
         </p:txBody>
@@ -6410,7 +8083,7 @@
                 </a:solidFill>
                 <a:latin typeface="Segoe UI"/>
               </a:rPr>
-              <a:t>PYTANIE DO PANI:  prosimy o weryfikację schematu (wiemy, że błędny schemat = odrzucenie projektu)</a:t>
+              <a:t>PYTANIE DO PANI:  prosimy o formalną weryfikację schematu</a:t>
             </a:r>
           </a:p>
         </p:txBody>
@@ -6594,7 +8267,7 @@
           <a:lstStyle/>
           <a:p>
             <a:r>
-              <a:rPr sz="1600" b="1">
+              <a:rPr sz="1500" b="1">
                 <a:solidFill>
                   <a:srgbClr val="1A1A2E"/>
                 </a:solidFill>
@@ -6605,7 +8278,7 @@
           </a:p>
           <a:p>
             <a:r>
-              <a:rPr sz="1600" b="0">
+              <a:rPr sz="1500" b="0">
                 <a:solidFill>
                   <a:srgbClr val="1A1A2E"/>
                 </a:solidFill>
@@ -6616,51 +8289,51 @@
           </a:p>
           <a:p>
             <a:r>
-              <a:rPr sz="1400" b="0">
+              <a:rPr sz="1300" b="0">
                 <a:solidFill>
                   <a:srgbClr val="6B6B7B"/>
                 </a:solidFill>
                 <a:latin typeface="Segoe UI"/>
               </a:rPr>
-              <a:t>   – wyjątek: event_id_cnty jako wymiar zdegenerowany (unikalny per wiersz — jak NrZamówienia z wykładu)</a:t>
-            </a:r>
-          </a:p>
-          <a:p>
-            <a:r>
-              <a:rPr sz="1600" b="0">
+              <a:t>   – wyjątek: event_id_cnty jako wymiar zdegenerowany (liczność = liczność faktu — jak NrZamówienia z wykładu)</a:t>
+            </a:r>
+          </a:p>
+          <a:p>
+            <a:r>
+              <a:rPr sz="1500" b="0">
                 <a:solidFill>
                   <a:srgbClr val="1A1A2E"/>
                 </a:solidFill>
                 <a:latin typeface="Segoe UI"/>
               </a:rPr>
-              <a:t>• Klucze sztuczne we wszystkich wymiarach (ROW_NUMBER; data = yyyymmdd)</a:t>
-            </a:r>
-          </a:p>
-          <a:p>
-            <a:r>
-              <a:rPr sz="1600" b="0">
+              <a:t>• Klucze sztuczne we wszystkich wymiarach (ROW_NUMBER; klucz daty = yyyymmdd)</a:t>
+            </a:r>
+          </a:p>
+          <a:p>
+            <a:r>
+              <a:rPr sz="1500" b="0">
                 <a:solidFill>
                   <a:srgbClr val="1A1A2E"/>
                 </a:solidFill>
                 <a:latin typeface="Segoe UI"/>
               </a:rPr>
-              <a:t>• interaction = NORMALNY wymiar (134 wartości — za mała liczność na zdegenerowany)</a:t>
-            </a:r>
-          </a:p>
-          <a:p>
-            <a:r>
-              <a:rPr sz="1600" b="0">
+              <a:t>• interaction = normalny wymiar (134 wartości — za mała liczność na zdegenerowany)</a:t>
+            </a:r>
+          </a:p>
+          <a:p>
+            <a:r>
+              <a:rPr sz="1500" b="0">
                 <a:solidFill>
                   <a:srgbClr val="1A1A2E"/>
                 </a:solidFill>
                 <a:latin typeface="Segoe UI"/>
               </a:rPr>
-              <a:t>• Pseudo-nulle → wiersz „Unknown" (id = −1) w każdym wymiarze (wykład 12)</a:t>
-            </a:r>
-          </a:p>
-          <a:p>
-            <a:r>
-              <a:rPr sz="1600" b="0">
+              <a:t>• Pseudo-nulle → wiersz „Unknown" (id = −1) w każdym wymiarze</a:t>
+            </a:r>
+          </a:p>
+          <a:p>
+            <a:r>
+              <a:rPr sz="1500" b="0">
                 <a:solidFill>
                   <a:srgbClr val="1A1A2E"/>
                 </a:solidFill>
@@ -6671,24 +8344,24 @@
           </a:p>
           <a:p>
             <a:r>
-              <a:rPr sz="1600" b="0">
+              <a:rPr sz="1500" b="0">
                 <a:solidFill>
                   <a:srgbClr val="1A1A2E"/>
                 </a:solidFill>
                 <a:latin typeface="Segoe UI"/>
               </a:rPr>
-              <a:t>• populacja: klucz złożony (iso, rok) spłaszczony do iso_year — relacje Power BI są 1-kolumnowe</a:t>
-            </a:r>
-          </a:p>
-          <a:p>
-            <a:r>
-              <a:rPr sz="1600" b="1">
+              <a:t>• populacja: klucz złożony (iso, rok) spłaszczony do iso_year (relacje PBI 1-kolumnowe); relacja Both — inaczej filtr kraju nie dociera do populacji</a:t>
+            </a:r>
+          </a:p>
+          <a:p>
+            <a:r>
+              <a:rPr sz="1500" b="1">
                 <a:solidFill>
                   <a:srgbClr val="1A1A2E"/>
                 </a:solidFill>
                 <a:latin typeface="Segoe UI"/>
               </a:rPr>
-              <a:t>• Zasady z wykładu 3: ≤25 wymiarów ✓ (7) · fakt ~160× większy od największego wymiaru ✓</a:t>
+              <a:t>• Zasady z wykładu: ≤25 wymiarów ✔ (7) · fakt ~160× większy od największego wymiaru ✔ · miary sumowalne ✔</a:t>
             </a:r>
           </a:p>
         </p:txBody>
@@ -6742,7 +8415,7 @@
                 </a:solidFill>
                 <a:latin typeface="Segoe UI"/>
               </a:rPr>
-              <a:t>PYTANIE DO PANI:  czy akceptuje Pani: degenerate event_id_cnty · klucz iso_year · lat/long poza gwiazdą (zostały w tabeli gold)?</a:t>
+              <a:t>PYTANIE DO PANI:  czy akceptuje Pani: degenerate event_id_cnty · klucz iso_year + relacja Both · lat/long poza gwiazdą (zostały w gold)?</a:t>
             </a:r>
           </a:p>
         </p:txBody>
@@ -6866,7 +8539,7 @@
             <a:avLst/>
           </a:prstGeom>
           <a:solidFill>
-            <a:srgbClr val="E08E45"/>
+            <a:srgbClr val="2E7D32"/>
           </a:solidFill>
           <a:ln>
             <a:noFill/>
@@ -6898,7 +8571,7 @@
                 </a:solidFill>
                 <a:latin typeface="Segoe UI"/>
               </a:rPr>
-              <a:t>wymóg: ETL 20 pkt</a:t>
+              <a:t>wymóg 20 pkt ✔</a:t>
             </a:r>
           </a:p>
         </p:txBody>
@@ -6976,7 +8649,7 @@
                 </a:solidFill>
                 <a:latin typeface="Segoe UI"/>
               </a:rPr>
-              <a:t>PYTANIE DO PANI:  czy stack AWS+Airflow+Power BI jest OK jako zamiennik SSIS/SSAS/SSRS? (wg dokumentu ARCHITEKTURA — tak)</a:t>
+              <a:t>PYTANIE DO PANI:  stack AWS + Airflow + Power BI jako zamiennik SSIS/SSAS/SSRS — zgodny z dokumentem ARCHITEKTURA?</a:t>
             </a:r>
           </a:p>
         </p:txBody>
@@ -7115,7 +8788,7 @@
                 </a:solidFill>
                 <a:latin typeface="Segoe UI"/>
               </a:rPr>
-              <a:t>pełna wersja: docs/etl_mapowania.md — źródło → transformacja → cel dla każdej kolumny</a:t>
+              <a:t>pełna wersja: docs/etl_mapowania.md — każda kolumna: źródło → transformacja → cel</a:t>
             </a:r>
           </a:p>
         </p:txBody>
@@ -7135,7 +8808,7 @@
             <a:avLst/>
           </a:prstGeom>
           <a:solidFill>
-            <a:srgbClr val="E08E45"/>
+            <a:srgbClr val="2E7D32"/>
           </a:solidFill>
           <a:ln>
             <a:noFill/>
@@ -7167,7 +8840,7 @@
                 </a:solidFill>
                 <a:latin typeface="Segoe UI"/>
               </a:rPr>
-              <a:t>zadanie ✓</a:t>
+              <a:t>zadanie ✔</a:t>
             </a:r>
           </a:p>
         </p:txBody>
@@ -7237,7 +8910,7 @@
                 </a:solidFill>
                 <a:latin typeface="Segoe UI"/>
               </a:rPr>
-              <a:t>Python, OAuth, paginacja, przyrostowo po timestamp; surowe CSV append-only</a:t>
+              <a:t>Python, OAuth, paginacja, przyrostowo po timestamp; CSV append-only</a:t>
             </a:r>
           </a:p>
         </p:txBody>
@@ -7250,7 +8923,7 @@
         </p:nvSpPr>
         <p:spPr>
           <a:xfrm>
-            <a:off x="548640" y="2167128"/>
+            <a:off x="548640" y="2148840"/>
             <a:ext cx="3108960" cy="731520"/>
           </a:xfrm>
           <a:prstGeom prst="rect">
@@ -7285,7 +8958,7 @@
         </p:nvSpPr>
         <p:spPr>
           <a:xfrm>
-            <a:off x="3749039" y="2167128"/>
+            <a:off x="3749039" y="2148840"/>
             <a:ext cx="7955279" cy="731520"/>
           </a:xfrm>
           <a:prstGeom prst="rect">
@@ -7320,7 +8993,7 @@
         </p:nvSpPr>
         <p:spPr>
           <a:xfrm>
-            <a:off x="548640" y="2916936"/>
+            <a:off x="548640" y="2880360"/>
             <a:ext cx="3108960" cy="731520"/>
           </a:xfrm>
           <a:prstGeom prst="rect">
@@ -7355,7 +9028,7 @@
         </p:nvSpPr>
         <p:spPr>
           <a:xfrm>
-            <a:off x="3749039" y="2916936"/>
+            <a:off x="3749039" y="2880360"/>
             <a:ext cx="7955279" cy="731520"/>
           </a:xfrm>
           <a:prstGeom prst="rect">
@@ -7377,7 +9050,7 @@
                 </a:solidFill>
                 <a:latin typeface="Segoe UI"/>
               </a:rPr>
-              <a:t>Athena CTAS: integracja (interaction z bronze — bug casta w silverze), flaga cywilów, czyszczenie</a:t>
+              <a:t>Athena CTAS: integracja, flaga cywilów, czyszczenie pseudo-nulli</a:t>
             </a:r>
           </a:p>
         </p:txBody>
@@ -7390,7 +9063,7 @@
         </p:nvSpPr>
         <p:spPr>
           <a:xfrm>
-            <a:off x="548640" y="3666744"/>
+            <a:off x="548640" y="3611880"/>
             <a:ext cx="3108960" cy="731520"/>
           </a:xfrm>
           <a:prstGeom prst="rect">
@@ -7425,7 +9098,7 @@
         </p:nvSpPr>
         <p:spPr>
           <a:xfrm>
-            <a:off x="3749039" y="3666744"/>
+            <a:off x="3749039" y="3611880"/>
             <a:ext cx="7955279" cy="731520"/>
           </a:xfrm>
           <a:prstGeom prst="rect">
@@ -7460,7 +9133,7 @@
         </p:nvSpPr>
         <p:spPr>
           <a:xfrm>
-            <a:off x="548640" y="4416552"/>
+            <a:off x="548640" y="4343400"/>
             <a:ext cx="3108960" cy="731520"/>
           </a:xfrm>
           <a:prstGeom prst="rect">
@@ -7482,7 +9155,7 @@
                 </a:solidFill>
                 <a:latin typeface="Segoe UI"/>
               </a:rPr>
-              <a:t>L2: gold+wymiary → fakt</a:t>
+              <a:t>L2: → fakt</a:t>
             </a:r>
           </a:p>
         </p:txBody>
@@ -7495,7 +9168,7 @@
         </p:nvSpPr>
         <p:spPr>
           <a:xfrm>
-            <a:off x="3749039" y="4416552"/>
+            <a:off x="3749039" y="4343400"/>
             <a:ext cx="7955279" cy="731520"/>
           </a:xfrm>
           <a:prstGeom prst="rect">
@@ -7530,7 +9203,7 @@
         </p:nvSpPr>
         <p:spPr>
           <a:xfrm>
-            <a:off x="548640" y="5166360"/>
+            <a:off x="548640" y="5074920"/>
             <a:ext cx="3108960" cy="731520"/>
           </a:xfrm>
           <a:prstGeom prst="rect">
@@ -7565,7 +9238,7 @@
         </p:nvSpPr>
         <p:spPr>
           <a:xfrm>
-            <a:off x="3749039" y="5166360"/>
+            <a:off x="3749039" y="5074920"/>
             <a:ext cx="7955279" cy="731520"/>
           </a:xfrm>
           <a:prstGeom prst="rect">
@@ -7641,7 +9314,7 @@
                 </a:solidFill>
                 <a:latin typeface="Segoe UI"/>
               </a:rPr>
-              <a:t>PYTANIE DO PANI:  czy taka forma tabeli mapowań odpowiada wzorowi z Materiałów?</a:t>
+              <a:t>PYTANIE DO PANI:  czy forma tabeli mapowań odpowiada wzorowi z Materiałów?</a:t>
             </a:r>
           </a:p>
         </p:txBody>
@@ -7745,14 +9418,49 @@
                 </a:solidFill>
                 <a:latin typeface="Segoe UI"/>
               </a:rPr>
-              <a:t>ETL na żywo — Airflow (pełny przebieg, wszystkie kroki zielone)</a:t>
-            </a:r>
-          </a:p>
-        </p:txBody>
-      </p:sp>
-      <p:sp>
-        <p:nvSpPr>
-          <p:cNvPr id="4" name="Rectangle 3"/>
+              <a:t>ETL na żywo — pełny przebieg w Airflow</a:t>
+            </a:r>
+          </a:p>
+        </p:txBody>
+      </p:sp>
+      <p:sp>
+        <p:nvSpPr>
+          <p:cNvPr id="4" name="TextBox 3"/>
+          <p:cNvSpPr txBox="1"/>
+          <p:nvPr/>
+        </p:nvSpPr>
+        <p:spPr>
+          <a:xfrm>
+            <a:off x="457200" y="868680"/>
+            <a:ext cx="11277295" cy="365760"/>
+          </a:xfrm>
+          <a:prstGeom prst="rect">
+            <a:avLst/>
+          </a:prstGeom>
+          <a:noFill/>
+        </p:spPr>
+        <p:txBody>
+          <a:bodyPr wrap="square">
+            <a:spAutoFit/>
+          </a:bodyPr>
+          <a:lstStyle/>
+          <a:p>
+            <a:pPr algn="l"/>
+            <a:r>
+              <a:rPr sz="1400" b="0">
+                <a:solidFill>
+                  <a:srgbClr val="6B6B7B"/>
+                </a:solidFill>
+                <a:latin typeface="Segoe UI"/>
+              </a:rPr>
+              <a:t>crawler → Spark → gold → gwiazda → walidacja; kroki idempotentne — możemy odpalić przy Pani</a:t>
+            </a:r>
+          </a:p>
+        </p:txBody>
+      </p:sp>
+      <p:sp>
+        <p:nvSpPr>
+          <p:cNvPr id="5" name="Rectangle 4"/>
           <p:cNvSpPr/>
           <p:nvPr/>
         </p:nvSpPr>
@@ -7765,7 +9473,7 @@
             <a:avLst/>
           </a:prstGeom>
           <a:solidFill>
-            <a:srgbClr val="E08E45"/>
+            <a:srgbClr val="2E7D32"/>
           </a:solidFill>
           <a:ln>
             <a:noFill/>
@@ -7797,14 +9505,14 @@
                 </a:solidFill>
                 <a:latin typeface="Segoe UI"/>
               </a:rPr>
-              <a:t>pokażemy live</a:t>
+              <a:t>demo live</a:t>
             </a:r>
           </a:p>
         </p:txBody>
       </p:sp>
       <p:pic>
         <p:nvPicPr>
-          <p:cNvPr id="5" name="Picture 4" descr="01_graf.png"/>
+          <p:cNvPr id="6" name="Picture 5" descr="01_graf.png"/>
           <p:cNvPicPr>
             <a:picLocks noChangeAspect="1"/>
           </p:cNvPicPr>
@@ -7818,49 +9526,14 @@
         </p:blipFill>
         <p:spPr>
           <a:xfrm>
-            <a:off x="2291944" y="1051560"/>
-            <a:ext cx="7607807" cy="4754880"/>
+            <a:off x="2218791" y="1234440"/>
+            <a:ext cx="7754112" cy="4846320"/>
           </a:xfrm>
           <a:prstGeom prst="rect">
             <a:avLst/>
           </a:prstGeom>
         </p:spPr>
       </p:pic>
-      <p:sp>
-        <p:nvSpPr>
-          <p:cNvPr id="6" name="TextBox 5"/>
-          <p:cNvSpPr txBox="1"/>
-          <p:nvPr/>
-        </p:nvSpPr>
-        <p:spPr>
-          <a:xfrm>
-            <a:off x="457200" y="5852160"/>
-            <a:ext cx="11277295" cy="365760"/>
-          </a:xfrm>
-          <a:prstGeom prst="rect">
-            <a:avLst/>
-          </a:prstGeom>
-          <a:noFill/>
-        </p:spPr>
-        <p:txBody>
-          <a:bodyPr wrap="square">
-            <a:spAutoFit/>
-          </a:bodyPr>
-          <a:lstStyle/>
-          <a:p>
-            <a:pPr algn="l"/>
-            <a:r>
-              <a:rPr sz="1300" b="0">
-                <a:solidFill>
-                  <a:srgbClr val="6B6B7B"/>
-                </a:solidFill>
-                <a:latin typeface="Segoe UI"/>
-              </a:rPr>
-              <a:t>2 DAG-i: acled_manual_backfill (API→silver, parametr full/incremental) + acled_pipeline (gold→gwiazda→walidacja). Kroki idempotentne — można odpalić przy Pani.</a:t>
-            </a:r>
-          </a:p>
-        </p:txBody>
-      </p:sp>
     </p:spTree>
   </p:cSld>
   <p:clrMapOvr>
@@ -8015,7 +9688,7 @@
             <a:avLst/>
           </a:prstGeom>
           <a:solidFill>
-            <a:srgbClr val="E08E45"/>
+            <a:srgbClr val="2E7D32"/>
           </a:solidFill>
           <a:ln>
             <a:noFill/>
@@ -8047,7 +9720,7 @@
                 </a:solidFill>
                 <a:latin typeface="Segoe UI"/>
               </a:rPr>
-              <a:t>zadanie ✓</a:t>
+              <a:t>zadanie ✔</a:t>
             </a:r>
           </a:p>
         </p:txBody>
@@ -8108,7 +9781,7 @@
         </p:nvSpPr>
         <p:spPr>
           <a:xfrm>
-            <a:off x="548640" y="5532120"/>
+            <a:off x="548640" y="5486400"/>
             <a:ext cx="5486400" cy="365760"/>
           </a:xfrm>
           <a:prstGeom prst="rect">
@@ -8143,7 +9816,7 @@
         </p:nvSpPr>
         <p:spPr>
           <a:xfrm>
-            <a:off x="6400800" y="5532120"/>
+            <a:off x="6400800" y="5486400"/>
             <a:ext cx="5486400" cy="365760"/>
           </a:xfrm>
           <a:prstGeom prst="rect">
@@ -8165,61 +9838,7 @@
                 </a:solidFill>
                 <a:latin typeface="Segoe UI"/>
               </a:rPr>
-              <a:t>walidacja (asserty rekoncyliacji) — SUCCESS</a:t>
-            </a:r>
-          </a:p>
-        </p:txBody>
-      </p:sp>
-      <p:sp>
-        <p:nvSpPr>
-          <p:cNvPr id="10" name="Rectangle 9"/>
-          <p:cNvSpPr/>
-          <p:nvPr/>
-        </p:nvSpPr>
-        <p:spPr>
-          <a:xfrm>
-            <a:off x="457200" y="5806440"/>
-            <a:ext cx="11277295" cy="777240"/>
-          </a:xfrm>
-          <a:prstGeom prst="rect">
-            <a:avLst/>
-          </a:prstGeom>
-          <a:solidFill>
-            <a:srgbClr val="FFFFFF"/>
-          </a:solidFill>
-          <a:ln w="19050">
-            <a:solidFill>
-              <a:srgbClr val="A50F15"/>
-            </a:solidFill>
-          </a:ln>
-        </p:spPr>
-        <p:style>
-          <a:lnRef idx="1">
-            <a:schemeClr val="accent1"/>
-          </a:lnRef>
-          <a:fillRef idx="3">
-            <a:schemeClr val="accent1"/>
-          </a:fillRef>
-          <a:effectRef idx="2">
-            <a:schemeClr val="accent1"/>
-          </a:effectRef>
-          <a:fontRef idx="minor">
-            <a:schemeClr val="lt1"/>
-          </a:fontRef>
-        </p:style>
-        <p:txBody>
-          <a:bodyPr rtlCol="0" anchor="ctr" wrap="square"/>
-          <a:lstStyle/>
-          <a:p>
-            <a:pPr algn="ctr"/>
-            <a:r>
-              <a:rPr sz="1500" b="1">
-                <a:solidFill>
-                  <a:srgbClr val="A50F15"/>
-                </a:solidFill>
-                <a:latin typeface="Segoe UI"/>
-              </a:rPr>
-              <a:t>PYTANIE DO PANI:  czy zrzuty z zadań Airflow spełniają wymóg „momentu udanej operacji ładowania"?</a:t>
+              <a:t>walidacja (rekoncyliacja warstw) — SUCCESS</a:t>
             </a:r>
           </a:p>
         </p:txBody>

</xml_diff>